<commit_message>
docs: revise three-minute pitch
</commit_message>
<xml_diff>
--- a/docs/pitch/Maestro-Agricola-Pitch.pptx
+++ b/docs/pitch/Maestro-Agricola-Pitch.pptx
@@ -2,18 +2,18 @@
 <file path=ppt/presentation.xml><?xml version="1.0" encoding="utf-8"?>
 <p:presentation xmlns:p="http://schemas.openxmlformats.org/presentationml/2006/main">
   <p:sldMasterIdLst>
-    <p:sldMasterId xmlns:r="http://schemas.openxmlformats.org/officeDocument/2006/relationships" id="2147483648" r:id="Rdd0380d9eb81451f"/>
+    <p:sldMasterId xmlns:r="http://schemas.openxmlformats.org/officeDocument/2006/relationships" id="2147483648" r:id="Rbd239dc8c01f4b8c"/>
   </p:sldMasterIdLst>
   <p:notesMasterIdLst>
-    <p:notesMasterId xmlns:r="http://schemas.openxmlformats.org/officeDocument/2006/relationships" r:id="R04e59e29b1d049ce"/>
+    <p:notesMasterId xmlns:r="http://schemas.openxmlformats.org/officeDocument/2006/relationships" r:id="R159d68aa0a2c48e5"/>
   </p:notesMasterIdLst>
   <p:sldIdLst>
-    <p:sldId xmlns:r="http://schemas.openxmlformats.org/officeDocument/2006/relationships" id="256" r:id="R6afa8560520d4689"/>
-    <p:sldId xmlns:r="http://schemas.openxmlformats.org/officeDocument/2006/relationships" id="257" r:id="R59ba0ad87d714515"/>
-    <p:sldId xmlns:r="http://schemas.openxmlformats.org/officeDocument/2006/relationships" id="258" r:id="R4f7099ef23064ef6"/>
-    <p:sldId xmlns:r="http://schemas.openxmlformats.org/officeDocument/2006/relationships" id="259" r:id="Rce80a728e0d74310"/>
-    <p:sldId xmlns:r="http://schemas.openxmlformats.org/officeDocument/2006/relationships" id="260" r:id="R844931d6e3884070"/>
-    <p:sldId xmlns:r="http://schemas.openxmlformats.org/officeDocument/2006/relationships" id="261" r:id="R7fc912c13c404582"/>
+    <p:sldId xmlns:r="http://schemas.openxmlformats.org/officeDocument/2006/relationships" id="256" r:id="Ra164d11e08b94571"/>
+    <p:sldId xmlns:r="http://schemas.openxmlformats.org/officeDocument/2006/relationships" id="257" r:id="R216c4fc55b594a48"/>
+    <p:sldId xmlns:r="http://schemas.openxmlformats.org/officeDocument/2006/relationships" id="258" r:id="Rff0b452be7694d13"/>
+    <p:sldId xmlns:r="http://schemas.openxmlformats.org/officeDocument/2006/relationships" id="259" r:id="R07997ddcee574f1e"/>
+    <p:sldId xmlns:r="http://schemas.openxmlformats.org/officeDocument/2006/relationships" id="260" r:id="Ra2cf5352040f4227"/>
+    <p:sldId xmlns:r="http://schemas.openxmlformats.org/officeDocument/2006/relationships" id="261" r:id="R6c39c2f5257343e4"/>
   </p:sldIdLst>
   <p:sldSz cx="12192000" cy="6858000"/>
   <p:notesSz cx="6858000" cy="9144000"/>
@@ -447,7 +447,7 @@
           <a:lstStyle xmlns:a="http://schemas.openxmlformats.org/drawingml/2006/main"/>
           <a:p xmlns:a="http://schemas.openxmlformats.org/drawingml/2006/main">
             <a:r>
-              <a:t>Imagine um operador no meio da lavoura, com as mãos ocupadas, tentando orientar um robô autônomo. A máquina já sabe navegar, mas a interface ainda exige parar o trabalho e abrir uma tela. O Maestro Agrícola muda isso: o operador olha, fala e comanda.</a:t>
+              <a:t>Imagine um operador no meio da lavoura, com as mãos ocupadas, acompanhando um robô autônomo. A máquina já navega; mesmo assim, indicar uma nova área ainda pode exigir parar e abrir uma tela. O Maestro Agrícola muda essa conversa: olhar, falar e confirmar.</a:t>
             </a:r>
           </a:p>
           <a:p xmlns:a="http://schemas.openxmlformats.org/drawingml/2006/main">
@@ -462,7 +462,7 @@
           </a:p>
           <a:p xmlns:a="http://schemas.openxmlformats.org/drawingml/2006/main">
             <a:r>
-              <a:t>- Versão Resumida - Maestro Agrícola (AI Glasses Brasil), equipe AgroTurtles, 2026.</a:t>
+              <a:t>- Versão Resumida — Maestro Agrícola, equipe AgroTurtles, 2026.</a:t>
             </a:r>
           </a:p>
           <a:p xmlns:a="http://schemas.openxmlformats.org/drawingml/2006/main">
@@ -537,7 +537,7 @@
           <a:lstStyle xmlns:a="http://schemas.openxmlformats.org/drawingml/2006/main"/>
           <a:p xmlns:a="http://schemas.openxmlformats.org/drawingml/2006/main">
             <a:r>
-              <a:t>Hoje, reprogramar uma rota no campo pode exigir notebook ou tablet, justamente em um ambiente de sol, poeira e operação contínua. Essa fricção reduz a produtividade e afasta a tecnologia de quem mais precisa usá-la. O problema não é a autonomia do robô. É a forma como o humano conversa com ela.</a:t>
+              <a:t>No sol, na poeira e com luvas, um notebook ou tablet adiciona atrito justamente onde a interface deveria desaparecer. Nosso usuário inicial é o operador que acompanha uma máquina conectada e precisa indicar rapidamente uma área de trabalho. O problema não é a autonomia do robô. É a forma como o humano conversa com ela.</a:t>
             </a:r>
           </a:p>
           <a:p xmlns:a="http://schemas.openxmlformats.org/drawingml/2006/main">
@@ -552,7 +552,7 @@
           </a:p>
           <a:p xmlns:a="http://schemas.openxmlformats.org/drawingml/2006/main">
             <a:r>
-              <a:t>- Versão Técnica - Maestro Agrícola (AI Glasses Brasil), equipe AgroTurtles, 2026.</a:t>
+              <a:t>- Versão Técnica — Maestro Agrícola, equipe AgroTurtles, 2026.</a:t>
             </a:r>
           </a:p>
         </p:txBody>
@@ -622,7 +622,7 @@
           <a:lstStyle xmlns:a="http://schemas.openxmlformats.org/drawingml/2006/main"/>
           <a:p xmlns:a="http://schemas.openxmlformats.org/drawingml/2006/main">
             <a:r>
-              <a:t>Com o Maestro, a jornada tem três passos. Primeiro, olhar: a câmera identifica o talhão ou alvo centralizado. Depois, falar: a inteligência artificial transforma “pulverizar esta área” em uma intenção estruturada. Por fim, confirmar: o sistema responde “pulverizar talhão três, confirmar?”. Só após o sim o comando é enviado. É uma interação natural, mãos-livres e com segurança explícita.</a:t>
+              <a:t>A jornada tem três ações. Olhar: um QR identifica o talhão três, associado a uma posição segura no mapa. Falar: o reconhecimento nativo transcreve “pulverizar esta área”, e uma IA pequena, local e restrita classifica a intenção. Confirmar: o sistema pergunta “pulverizar talhão três?”. Só o sim libera o JSON. Se houver ambiguidade ou o usuário disser “cancelar”, nenhum comando chega ao robô.</a:t>
             </a:r>
           </a:p>
           <a:p xmlns:a="http://schemas.openxmlformats.org/drawingml/2006/main">
@@ -637,12 +637,12 @@
           </a:p>
           <a:p xmlns:a="http://schemas.openxmlformats.org/drawingml/2006/main">
             <a:r>
-              <a:t>- Edital AI Glasses Brasil 2026, seções 7, 8.1 e 11.2.</a:t>
-            </a:r>
-          </a:p>
-          <a:p xmlns:a="http://schemas.openxmlformats.org/drawingml/2006/main">
-            <a:r>
-              <a:t>- Meta Wearables DAT Android CameraAccess sample: https://github.com/facebook/meta-wearables-dat-android/tree/main/samples/CameraAccess</a:t>
+              <a:t>- Meta Wearables DAT CameraAccess: https://github.com/facebook/meta-wearables-dat-android/tree/main/samples/CameraAccess</a:t>
+            </a:r>
+          </a:p>
+          <a:p xmlns:a="http://schemas.openxmlformats.org/drawingml/2006/main">
+            <a:r>
+              <a:t>- docs/mvp-spec.md e docs/submission/final-form.md, equipe AgroTurtles, 2026.</a:t>
             </a:r>
           </a:p>
         </p:txBody>
@@ -712,7 +712,7 @@
           <a:lstStyle xmlns:a="http://schemas.openxmlformats.org/drawingml/2006/main"/>
           <a:p xmlns:a="http://schemas.openxmlformats.org/drawingml/2006/main">
             <a:r>
-              <a:t>O protótipo é simples e modular. Os óculos fornecem câmera, microfone e áudio. O app Android em Kotlin usa o DAT, interpreta voz e alvo localmente e envia um JSON por WebSocket. Um bridge ROS 2 transforma esse comando em uma meta no Gazebo. Antes de receber o hardware, validamos sessão, câmera e falhas com o Mock Device Kit. E tomamos uma decisão importante de viabilidade: como o DAT atual não expõe pose ou IMU dos óculos, o MVP usa um alvo visual previamente mapeado. Assim demonstramos a experiência completa sem depender de uma API inexistente.</a:t>
+              <a:t>Por dentro, a câmera entra pelo DAT. Voz e TTS usam recursos nativos do celular e tentam a rota Bluetooth, com o telefone como fallback. Kotlin e Swift consomem a mesma IA local e o mesmo contrato. Após a confirmação, um JSON com validade curta chega ao bridge, que valida e entrega uma meta ao Nav2 no Gazebo. Como o DAT público não documenta pose ou IMU, o MVP usa QR mapeado e isola a integração real no adaptador de câmera.</a:t>
             </a:r>
           </a:p>
           <a:p xmlns:a="http://schemas.openxmlformats.org/drawingml/2006/main">
@@ -727,17 +727,17 @@
           </a:p>
           <a:p xmlns:a="http://schemas.openxmlformats.org/drawingml/2006/main">
             <a:r>
-              <a:t>- Meta Wearables DAT Android CameraAccess sample: https://github.com/facebook/meta-wearables-dat-android/tree/main/samples/CameraAccess</a:t>
-            </a:r>
-          </a:p>
-          <a:p xmlns:a="http://schemas.openxmlformats.org/drawingml/2006/main">
-            <a:r>
-              <a:t>- Un13 Material de apoio Meta, tópicos 13.2, 13.5, 13.6 e 13.7.</a:t>
-            </a:r>
-          </a:p>
-          <a:p xmlns:a="http://schemas.openxmlformats.org/drawingml/2006/main">
-            <a:r>
-              <a:t>- Feature request for IMU/head-pose access in DAT: https://github.com/facebook/meta-wearables-dat-ios/discussions/84</a:t>
+              <a:t>- Meta Wearables Developer Center: https://wearables.developer.meta.com/docs/develop/dat/getting-started-toolkit</a:t>
+            </a:r>
+          </a:p>
+          <a:p xmlns:a="http://schemas.openxmlformats.org/drawingml/2006/main">
+            <a:r>
+              <a:t>- Meta Wearables DAT Android e iOS CameraAccess samples: https://github.com/facebook/meta-wearables-dat-android/tree/main/samples/CameraAccess e https://github.com/facebook/meta-wearables-dat-ios/tree/main/samples/CameraAccess</a:t>
+            </a:r>
+          </a:p>
+          <a:p xmlns:a="http://schemas.openxmlformats.org/drawingml/2006/main">
+            <a:r>
+              <a:t>- A ausência de pose/IMU é uma inferência a partir das APIs públicas consultadas; validar novamente contra a versão do SDK usada no evento.</a:t>
             </a:r>
           </a:p>
         </p:txBody>
@@ -807,7 +807,7 @@
           <a:lstStyle xmlns:a="http://schemas.openxmlformats.org/drawingml/2006/main"/>
           <a:p xmlns:a="http://schemas.openxmlformats.org/drawingml/2006/main">
             <a:r>
-              <a:t>O Maestro atende aos cinco checkpoints: inteligência artificial funcional, câmera e microfone como entrada, áudio como saída, privacidade e eficiência. Capturamos apenas quando há comando e descartamos a imagem após o processamento. Nenhum movimento acontece sem confirmação, e a navegação segura continua sob responsabilidade do próprio robô. O resultado é uma solução agnóstica de fabricante e pronta para validação.</a:t>
+              <a:t>Hoje já provamos o ciclo na simulação. O cliente enviou “pulverizar esta área”, recebeu ACCEPTED, o Nav2 ficou ativo e a odometria do TurtleBot mudou. “Cancelar” foi recusado localmente, sem movimento. O desenho cobre os cinco pilares: IA, câmera e voz, saída por áudio, privacidade e eficiência por captura sob demanda. O próximo passo é compilar nos dois aparelhos e validar DAT, latência, bateria e rota Bluetooth com os óculos reais.</a:t>
             </a:r>
           </a:p>
           <a:p xmlns:a="http://schemas.openxmlformats.org/drawingml/2006/main">
@@ -822,12 +822,17 @@
           </a:p>
           <a:p xmlns:a="http://schemas.openxmlformats.org/drawingml/2006/main">
             <a:r>
-              <a:t>- Edital AI Glasses Brasil 2026, seção 8.1 (checkpoints técnicos obrigatórios).</a:t>
-            </a:r>
-          </a:p>
-          <a:p xmlns:a="http://schemas.openxmlformats.org/drawingml/2006/main">
-            <a:r>
-              <a:t>- Un12 Material de apoio Meta, tópicos de eficiência, visão e voz.</a:t>
+              <a:t>- docs/tasks/submission-readiness.md: execução local de 18 ago. 2026.</a:t>
+            </a:r>
+          </a:p>
+          <a:p xmlns:a="http://schemas.openxmlformats.org/drawingml/2006/main">
+            <a:r>
+              <a:t>- docs/testing.md e saída de make demo: ACCEPTED, Nav2 ativo e odometria alterada.</a:t>
+            </a:r>
+          </a:p>
+          <a:p xmlns:a="http://schemas.openxmlformats.org/drawingml/2006/main">
+            <a:r>
+              <a:t>- Palestras finais do CEIA analisadas em docs/references/ceia-materials.md.</a:t>
             </a:r>
           </a:p>
         </p:txBody>
@@ -897,7 +902,7 @@
           <a:lstStyle xmlns:a="http://schemas.openxmlformats.org/drawingml/2006/main"/>
           <a:p xmlns:a="http://schemas.openxmlformats.org/drawingml/2006/main">
             <a:r>
-              <a:t>O futuro do campo não precisa de mais uma tela. Precisa de uma interface que entenda onde o operador olha, o que ele pede e quando é seguro agir. Maestro Agrícola: olhe, fale, confirme.</a:t>
+              <a:t>A John Deere mostra o valor de acompanhar máquinas pelo celular; a Meta mostra os óculos como interface multimodal. O Maestro conecta esses mundos com protocolo aberto, confirmação obrigatória e ROS 2, sem se prender a um fabricante. O futuro do campo não precisa de mais uma tela. Precisa entender alvo, intenção e segurança. Maestro Agrícola: olhe, fale, confirme.</a:t>
             </a:r>
           </a:p>
           <a:p xmlns:a="http://schemas.openxmlformats.org/drawingml/2006/main">
@@ -912,7 +917,17 @@
           </a:p>
           <a:p xmlns:a="http://schemas.openxmlformats.org/drawingml/2006/main">
             <a:r>
-              <a:t>- Síntese da proposta da equipe AgroTurtles, 2026.</a:t>
+              <a:t>- Meta AI: https://ai.meta.com/meta-ai/</a:t>
+            </a:r>
+          </a:p>
+          <a:p xmlns:a="http://schemas.openxmlformats.org/drawingml/2006/main">
+            <a:r>
+              <a:t>- John Deere Operations Center: https://www.deere.com/en/technology-products/precision-ag-technology/operations-center/</a:t>
+            </a:r>
+          </a:p>
+          <a:p xmlns:a="http://schemas.openxmlformats.org/drawingml/2006/main">
+            <a:r>
+              <a:t>- Síntese e diferenciação em docs/submission/final-form.md.</a:t>
             </a:r>
           </a:p>
         </p:txBody>
@@ -980,7 +995,7 @@
   </p:cSld>
   <p:clrMap bg1="lt1" tx1="dk1" bg2="lt2" tx2="dk2" accent1="accent1" accent2="accent2" accent3="accent3" accent4="accent4" accent5="accent5" accent6="accent6" hlink="hlink" folHlink="folHlink"/>
   <p:sldLayoutIdLst>
-    <p:sldLayoutId xmlns:r="http://schemas.openxmlformats.org/officeDocument/2006/relationships" id="2147483649" r:id="R18dc9b724a764578"/>
+    <p:sldLayoutId xmlns:r="http://schemas.openxmlformats.org/officeDocument/2006/relationships" id="2147483649" r:id="Rc6602b5e9eec4503"/>
   </p:sldLayoutIdLst>
   <p:txStyles>
     <p:titleStyle>
@@ -1592,6 +1607,7 @@
           <a:lstStyle xmlns:a="http://schemas.openxmlformats.org/drawingml/2006/main"/>
           <a:p xmlns:a="http://schemas.openxmlformats.org/drawingml/2006/main">
             <a:pPr algn="l">
+              <a:buNone/>
               <a:defRPr sz="5700" b="1">
                 <a:solidFill>
                   <a:srgbClr val="111814"/>
@@ -1650,6 +1666,7 @@
           <a:lstStyle xmlns:a="http://schemas.openxmlformats.org/drawingml/2006/main"/>
           <a:p xmlns:a="http://schemas.openxmlformats.org/drawingml/2006/main">
             <a:pPr algn="l">
+              <a:buNone/>
               <a:defRPr sz="3600" b="1">
                 <a:solidFill>
                   <a:srgbClr val="174A2B"/>
@@ -1668,7 +1685,7 @@
                 <a:ea typeface="Arial"/>
                 <a:cs typeface="Arial"/>
               </a:rPr>
-              <a:t>Olhe. Fale. Comande.</a:t>
+              <a:t>Olhe. Fale. Confirme.</a:t>
             </a:r>
           </a:p>
         </p:txBody>
@@ -1708,6 +1725,7 @@
           <a:lstStyle xmlns:a="http://schemas.openxmlformats.org/drawingml/2006/main"/>
           <a:p xmlns:a="http://schemas.openxmlformats.org/drawingml/2006/main">
             <a:pPr algn="l">
+              <a:buNone/>
               <a:defRPr sz="2100" b="0">
                 <a:solidFill>
                   <a:srgbClr val="5E6B62"/>
@@ -1766,6 +1784,7 @@
           <a:lstStyle xmlns:a="http://schemas.openxmlformats.org/drawingml/2006/main"/>
           <a:p xmlns:a="http://schemas.openxmlformats.org/drawingml/2006/main">
             <a:pPr algn="l">
+              <a:buNone/>
               <a:defRPr sz="1500" b="1">
                 <a:solidFill>
                   <a:srgbClr val="5E6B62"/>
@@ -1791,14 +1810,14 @@
       </p:sp>
       <p:pic>
         <p:nvPicPr>
-          <p:cNvPr id="13" name=""/>
+          <p:cNvPr id="15" name=""/>
           <p:cNvPicPr>
             <a:picLocks xmlns:a="http://schemas.openxmlformats.org/drawingml/2006/main" noChangeAspect="1"/>
           </p:cNvPicPr>
           <p:nvPr/>
         </p:nvPicPr>
         <p:blipFill>
-          <a:blip xmlns:r="http://schemas.openxmlformats.org/officeDocument/2006/relationships" xmlns:a="http://schemas.openxmlformats.org/drawingml/2006/main" r:embed="Ra3e66f67e4ce462c"/>
+          <a:blip xmlns:r="http://schemas.openxmlformats.org/officeDocument/2006/relationships" xmlns:a="http://schemas.openxmlformats.org/drawingml/2006/main" r:embed="Rd889c7481aeb4128"/>
           <a:srcRect xmlns:a="http://schemas.openxmlformats.org/drawingml/2006/main" l="1105" t="0" r="1105" b="0"/>
           <a:stretch xmlns:a="http://schemas.openxmlformats.org/drawingml/2006/main">
             <a:fillRect l="0" t="0" r="0" b="0"/>
@@ -1851,6 +1870,7 @@
           <a:lstStyle xmlns:a="http://schemas.openxmlformats.org/drawingml/2006/main"/>
           <a:p xmlns:a="http://schemas.openxmlformats.org/drawingml/2006/main">
             <a:pPr algn="r">
+              <a:buNone/>
               <a:defRPr sz="1200" b="0">
                 <a:solidFill>
                   <a:srgbClr val="5E6B62"/>
@@ -1938,6 +1958,7 @@
           <a:lstStyle xmlns:a="http://schemas.openxmlformats.org/drawingml/2006/main"/>
           <a:p xmlns:a="http://schemas.openxmlformats.org/drawingml/2006/main">
             <a:pPr algn="l">
+              <a:buNone/>
               <a:defRPr sz="1500" b="1">
                 <a:solidFill>
                   <a:srgbClr val="2F7D4A"/>
@@ -1996,6 +2017,7 @@
           <a:lstStyle xmlns:a="http://schemas.openxmlformats.org/drawingml/2006/main"/>
           <a:p xmlns:a="http://schemas.openxmlformats.org/drawingml/2006/main">
             <a:pPr algn="l">
+              <a:buNone/>
               <a:defRPr sz="5550" b="1">
                 <a:solidFill>
                   <a:srgbClr val="111814"/>
@@ -2019,6 +2041,7 @@
           </a:p>
           <a:p xmlns:a="http://schemas.openxmlformats.org/drawingml/2006/main">
             <a:pPr algn="l">
+              <a:buNone/>
               <a:defRPr sz="5550" b="1">
                 <a:solidFill>
                   <a:srgbClr val="111814"/>
@@ -2108,6 +2131,7 @@
           <a:lstStyle xmlns:a="http://schemas.openxmlformats.org/drawingml/2006/main"/>
           <a:p xmlns:a="http://schemas.openxmlformats.org/drawingml/2006/main">
             <a:pPr algn="l">
+              <a:buNone/>
               <a:defRPr sz="2100" b="0">
                 <a:solidFill>
                   <a:srgbClr val="5E6B62"/>
@@ -2166,6 +2190,7 @@
           <a:lstStyle xmlns:a="http://schemas.openxmlformats.org/drawingml/2006/main"/>
           <a:p xmlns:a="http://schemas.openxmlformats.org/drawingml/2006/main">
             <a:pPr algn="l">
+              <a:buNone/>
               <a:defRPr sz="1800" b="1">
                 <a:solidFill>
                   <a:srgbClr val="174A2B"/>
@@ -2224,6 +2249,7 @@
           <a:lstStyle xmlns:a="http://schemas.openxmlformats.org/drawingml/2006/main"/>
           <a:p xmlns:a="http://schemas.openxmlformats.org/drawingml/2006/main">
             <a:pPr algn="r">
+              <a:buNone/>
               <a:defRPr sz="1200" b="0">
                 <a:solidFill>
                   <a:srgbClr val="5E6B62"/>
@@ -2311,6 +2337,7 @@
           <a:lstStyle xmlns:a="http://schemas.openxmlformats.org/drawingml/2006/main"/>
           <a:p xmlns:a="http://schemas.openxmlformats.org/drawingml/2006/main">
             <a:pPr algn="l">
+              <a:buNone/>
               <a:defRPr sz="3900" b="1">
                 <a:solidFill>
                   <a:srgbClr val="111814"/>
@@ -2435,6 +2462,7 @@
           <a:lstStyle xmlns:a="http://schemas.openxmlformats.org/drawingml/2006/main"/>
           <a:p xmlns:a="http://schemas.openxmlformats.org/drawingml/2006/main">
             <a:pPr algn="l">
+              <a:buNone/>
               <a:defRPr sz="1800" b="1">
                 <a:solidFill>
                   <a:srgbClr val="174A2B"/>
@@ -2493,6 +2521,7 @@
           <a:lstStyle xmlns:a="http://schemas.openxmlformats.org/drawingml/2006/main"/>
           <a:p xmlns:a="http://schemas.openxmlformats.org/drawingml/2006/main">
             <a:pPr algn="l">
+              <a:buNone/>
               <a:defRPr sz="1950" b="0">
                 <a:solidFill>
                   <a:srgbClr val="111814"/>
@@ -2511,7 +2540,7 @@
                 <a:ea typeface="Arial"/>
                 <a:cs typeface="Arial"/>
               </a:rPr>
-              <a:t>A câmera reconhece o alvo centralizado.</a:t>
+              <a:t>O QR identifica o talhão centralizado.</a:t>
             </a:r>
           </a:p>
         </p:txBody>
@@ -2586,6 +2615,7 @@
           <a:lstStyle xmlns:a="http://schemas.openxmlformats.org/drawingml/2006/main"/>
           <a:p xmlns:a="http://schemas.openxmlformats.org/drawingml/2006/main">
             <a:pPr algn="l">
+              <a:buNone/>
               <a:defRPr sz="1800" b="1">
                 <a:solidFill>
                   <a:srgbClr val="174A2B"/>
@@ -2644,6 +2674,7 @@
           <a:lstStyle xmlns:a="http://schemas.openxmlformats.org/drawingml/2006/main"/>
           <a:p xmlns:a="http://schemas.openxmlformats.org/drawingml/2006/main">
             <a:pPr algn="l">
+              <a:buNone/>
               <a:defRPr sz="1950" b="0">
                 <a:solidFill>
                   <a:srgbClr val="111814"/>
@@ -2662,7 +2693,7 @@
                 <a:ea typeface="Arial"/>
                 <a:cs typeface="Arial"/>
               </a:rPr>
-              <a:t>A IA transforma voz em intenção estruturada.</a:t>
+              <a:t>A voz vira uma intenção local e restrita.</a:t>
             </a:r>
           </a:p>
         </p:txBody>
@@ -2737,6 +2768,7 @@
           <a:lstStyle xmlns:a="http://schemas.openxmlformats.org/drawingml/2006/main"/>
           <a:p xmlns:a="http://schemas.openxmlformats.org/drawingml/2006/main">
             <a:pPr algn="l">
+              <a:buNone/>
               <a:defRPr sz="1800" b="1">
                 <a:solidFill>
                   <a:srgbClr val="174A2B"/>
@@ -2795,6 +2827,7 @@
           <a:lstStyle xmlns:a="http://schemas.openxmlformats.org/drawingml/2006/main"/>
           <a:p xmlns:a="http://schemas.openxmlformats.org/drawingml/2006/main">
             <a:pPr algn="l">
+              <a:buNone/>
               <a:defRPr sz="1950" b="0">
                 <a:solidFill>
                   <a:srgbClr val="111814"/>
@@ -2813,7 +2846,7 @@
                 <a:ea typeface="Arial"/>
                 <a:cs typeface="Arial"/>
               </a:rPr>
-              <a:t>O áudio confirma antes de qualquer movimento.</a:t>
+              <a:t>Só o ‘sim’ libera o comando ao robô.</a:t>
             </a:r>
           </a:p>
         </p:txBody>
@@ -2886,6 +2919,7 @@
           <a:lstStyle xmlns:a="http://schemas.openxmlformats.org/drawingml/2006/main"/>
           <a:p xmlns:a="http://schemas.openxmlformats.org/drawingml/2006/main">
             <a:pPr algn="ctr">
+              <a:buNone/>
               <a:defRPr sz="1875" b="1">
                 <a:solidFill>
                   <a:srgbClr val="174A2B"/>
@@ -2904,7 +2938,7 @@
                 <a:ea typeface="Arial"/>
                 <a:cs typeface="Arial"/>
               </a:rPr>
-              <a:t>Regra de segurança: sem confirmação, sem comando.</a:t>
+              <a:t>Falha segura: ambiguidade ou ‘cancelar’ = nenhum comando.</a:t>
             </a:r>
           </a:p>
         </p:txBody>
@@ -2944,6 +2978,7 @@
           <a:lstStyle xmlns:a="http://schemas.openxmlformats.org/drawingml/2006/main"/>
           <a:p xmlns:a="http://schemas.openxmlformats.org/drawingml/2006/main">
             <a:pPr algn="r">
+              <a:buNone/>
               <a:defRPr sz="1200" b="0">
                 <a:solidFill>
                   <a:srgbClr val="5E6B62"/>
@@ -3031,6 +3066,7 @@
           <a:lstStyle xmlns:a="http://schemas.openxmlformats.org/drawingml/2006/main"/>
           <a:p xmlns:a="http://schemas.openxmlformats.org/drawingml/2006/main">
             <a:pPr algn="l">
+              <a:buNone/>
               <a:defRPr sz="3900" b="1">
                 <a:solidFill>
                   <a:srgbClr val="111814"/>
@@ -3049,7 +3085,7 @@
                 <a:ea typeface="Arial"/>
                 <a:cs typeface="Arial"/>
               </a:rPr>
-              <a:t>Um corte vertical comprovável em um dia.</a:t>
+              <a:t>O ciclo completo já funciona em simulação.</a:t>
             </a:r>
           </a:p>
         </p:txBody>
@@ -3248,6 +3284,7 @@
           <a:lstStyle xmlns:a="http://schemas.openxmlformats.org/drawingml/2006/main"/>
           <a:p xmlns:a="http://schemas.openxmlformats.org/drawingml/2006/main">
             <a:pPr algn="ctr">
+              <a:buNone/>
               <a:defRPr sz="2025" b="1">
                 <a:solidFill>
                   <a:srgbClr val="111814"/>
@@ -3306,6 +3343,7 @@
           <a:lstStyle xmlns:a="http://schemas.openxmlformats.org/drawingml/2006/main"/>
           <a:p xmlns:a="http://schemas.openxmlformats.org/drawingml/2006/main">
             <a:pPr algn="ctr">
+              <a:buNone/>
               <a:defRPr sz="1650" b="0">
                 <a:solidFill>
                   <a:srgbClr val="5E6B62"/>
@@ -3324,11 +3362,12 @@
                 <a:ea typeface="Arial"/>
                 <a:cs typeface="Arial"/>
               </a:rPr>
-              <a:t>câmera</a:t>
+              <a:t>câmera via DAT</a:t>
             </a:r>
           </a:p>
           <a:p xmlns:a="http://schemas.openxmlformats.org/drawingml/2006/main">
             <a:pPr algn="ctr">
+              <a:buNone/>
               <a:defRPr sz="1650" b="0">
                 <a:solidFill>
                   <a:srgbClr val="5E6B62"/>
@@ -3347,11 +3386,12 @@
                 <a:ea typeface="Arial"/>
                 <a:cs typeface="Arial"/>
               </a:rPr>
-              <a:t>voz</a:t>
+              <a:t>áudio do sistema</a:t>
             </a:r>
           </a:p>
           <a:p xmlns:a="http://schemas.openxmlformats.org/drawingml/2006/main">
             <a:pPr algn="ctr">
+              <a:buNone/>
               <a:defRPr sz="1650" b="0">
                 <a:solidFill>
                   <a:srgbClr val="5E6B62"/>
@@ -3370,7 +3410,7 @@
                 <a:ea typeface="Arial"/>
                 <a:cs typeface="Arial"/>
               </a:rPr>
-              <a:t>áudio</a:t>
+              <a:t>rota a validar</a:t>
             </a:r>
           </a:p>
         </p:txBody>
@@ -3476,6 +3516,7 @@
           <a:lstStyle xmlns:a="http://schemas.openxmlformats.org/drawingml/2006/main"/>
           <a:p xmlns:a="http://schemas.openxmlformats.org/drawingml/2006/main">
             <a:pPr algn="ctr">
+              <a:buNone/>
               <a:defRPr sz="2025" b="1">
                 <a:solidFill>
                   <a:srgbClr val="111814"/>
@@ -3494,7 +3535,7 @@
                 <a:ea typeface="Arial"/>
                 <a:cs typeface="Arial"/>
               </a:rPr>
-              <a:t>Android / Kotlin</a:t>
+              <a:t>App nativo</a:t>
             </a:r>
           </a:p>
         </p:txBody>
@@ -3534,6 +3575,7 @@
           <a:lstStyle xmlns:a="http://schemas.openxmlformats.org/drawingml/2006/main"/>
           <a:p xmlns:a="http://schemas.openxmlformats.org/drawingml/2006/main">
             <a:pPr algn="ctr">
+              <a:buNone/>
               <a:defRPr sz="1650" b="0">
                 <a:solidFill>
                   <a:srgbClr val="5E6B62"/>
@@ -3552,11 +3594,12 @@
                 <a:ea typeface="Arial"/>
                 <a:cs typeface="Arial"/>
               </a:rPr>
-              <a:t>DAT</a:t>
+              <a:t>Kotlin / Swift</a:t>
             </a:r>
           </a:p>
           <a:p xmlns:a="http://schemas.openxmlformats.org/drawingml/2006/main">
             <a:pPr algn="ctr">
+              <a:buNone/>
               <a:defRPr sz="1650" b="0">
                 <a:solidFill>
                   <a:srgbClr val="5E6B62"/>
@@ -3580,6 +3623,7 @@
           </a:p>
           <a:p xmlns:a="http://schemas.openxmlformats.org/drawingml/2006/main">
             <a:pPr algn="ctr">
+              <a:buNone/>
               <a:defRPr sz="1650" b="0">
                 <a:solidFill>
                   <a:srgbClr val="5E6B62"/>
@@ -3704,6 +3748,7 @@
           <a:lstStyle xmlns:a="http://schemas.openxmlformats.org/drawingml/2006/main"/>
           <a:p xmlns:a="http://schemas.openxmlformats.org/drawingml/2006/main">
             <a:pPr algn="ctr">
+              <a:buNone/>
               <a:defRPr sz="2025" b="1">
                 <a:solidFill>
                   <a:srgbClr val="111814"/>
@@ -3762,6 +3807,7 @@
           <a:lstStyle xmlns:a="http://schemas.openxmlformats.org/drawingml/2006/main"/>
           <a:p xmlns:a="http://schemas.openxmlformats.org/drawingml/2006/main">
             <a:pPr algn="ctr">
+              <a:buNone/>
               <a:defRPr sz="1650" b="0">
                 <a:solidFill>
                   <a:srgbClr val="5E6B62"/>
@@ -3785,6 +3831,7 @@
           </a:p>
           <a:p xmlns:a="http://schemas.openxmlformats.org/drawingml/2006/main">
             <a:pPr algn="ctr">
+              <a:buNone/>
               <a:defRPr sz="1650" b="0">
                 <a:solidFill>
                   <a:srgbClr val="5E6B62"/>
@@ -3808,6 +3855,7 @@
           </a:p>
           <a:p xmlns:a="http://schemas.openxmlformats.org/drawingml/2006/main">
             <a:pPr algn="ctr">
+              <a:buNone/>
               <a:defRPr sz="1650" b="0">
                 <a:solidFill>
                   <a:srgbClr val="5E6B62"/>
@@ -3932,6 +3980,7 @@
           <a:lstStyle xmlns:a="http://schemas.openxmlformats.org/drawingml/2006/main"/>
           <a:p xmlns:a="http://schemas.openxmlformats.org/drawingml/2006/main">
             <a:pPr algn="ctr">
+              <a:buNone/>
               <a:defRPr sz="2025" b="1">
                 <a:solidFill>
                   <a:srgbClr val="111814"/>
@@ -3950,7 +3999,7 @@
                 <a:ea typeface="Arial"/>
                 <a:cs typeface="Arial"/>
               </a:rPr>
-              <a:t>ROS 2 / Gazebo</a:t>
+              <a:t>ROS 2 / Nav2</a:t>
             </a:r>
           </a:p>
         </p:txBody>
@@ -3990,6 +4039,7 @@
           <a:lstStyle xmlns:a="http://schemas.openxmlformats.org/drawingml/2006/main"/>
           <a:p xmlns:a="http://schemas.openxmlformats.org/drawingml/2006/main">
             <a:pPr algn="ctr">
+              <a:buNone/>
               <a:defRPr sz="1650" b="0">
                 <a:solidFill>
                   <a:srgbClr val="5E6B62"/>
@@ -4013,6 +4063,7 @@
           </a:p>
           <a:p xmlns:a="http://schemas.openxmlformats.org/drawingml/2006/main">
             <a:pPr algn="ctr">
+              <a:buNone/>
               <a:defRPr sz="1650" b="0">
                 <a:solidFill>
                   <a:srgbClr val="5E6B62"/>
@@ -4031,11 +4082,12 @@
                 <a:ea typeface="Arial"/>
                 <a:cs typeface="Arial"/>
               </a:rPr>
-              <a:t>meta de navegação</a:t>
+              <a:t>Gazebo</a:t>
             </a:r>
           </a:p>
           <a:p xmlns:a="http://schemas.openxmlformats.org/drawingml/2006/main">
             <a:pPr algn="ctr">
+              <a:buNone/>
               <a:defRPr sz="1650" b="0">
                 <a:solidFill>
                   <a:srgbClr val="5E6B62"/>
@@ -4054,7 +4106,7 @@
                 <a:ea typeface="Arial"/>
                 <a:cs typeface="Arial"/>
               </a:rPr>
-              <a:t>robô simulado</a:t>
+              <a:t>TurtleBot 4</a:t>
             </a:r>
           </a:p>
         </p:txBody>
@@ -4127,6 +4179,7 @@
           <a:lstStyle xmlns:a="http://schemas.openxmlformats.org/drawingml/2006/main"/>
           <a:p xmlns:a="http://schemas.openxmlformats.org/drawingml/2006/main">
             <a:pPr algn="ctr">
+              <a:buNone/>
               <a:defRPr sz="1875" b="1">
                 <a:solidFill>
                   <a:srgbClr val="174A2B"/>
@@ -4145,7 +4198,7 @@
                 <a:ea typeface="Arial"/>
                 <a:cs typeface="Arial"/>
               </a:rPr>
-              <a:t>MVP: alvo visual mapeado — sem depender de IMU ou pose que o DAT não expõe.</a:t>
+              <a:t>MVP: QR mapeado — sem depender de pose/IMU que o DAT público não expõe.</a:t>
             </a:r>
           </a:p>
         </p:txBody>
@@ -4185,6 +4238,7 @@
           <a:lstStyle xmlns:a="http://schemas.openxmlformats.org/drawingml/2006/main"/>
           <a:p xmlns:a="http://schemas.openxmlformats.org/drawingml/2006/main">
             <a:pPr algn="r">
+              <a:buNone/>
               <a:defRPr sz="1200" b="0">
                 <a:solidFill>
                   <a:srgbClr val="5E6B62"/>
@@ -4272,6 +4326,7 @@
           <a:lstStyle xmlns:a="http://schemas.openxmlformats.org/drawingml/2006/main"/>
           <a:p xmlns:a="http://schemas.openxmlformats.org/drawingml/2006/main">
             <a:pPr algn="l">
+              <a:buNone/>
               <a:defRPr sz="3900" b="1">
                 <a:solidFill>
                   <a:srgbClr val="111814"/>
@@ -4290,7 +4345,7 @@
                 <a:ea typeface="Arial"/>
                 <a:cs typeface="Arial"/>
               </a:rPr>
-              <a:t>Viável, responsável e pronto para validar.</a:t>
+              <a:t>A simulação já fecha o ciclo com falha segura.</a:t>
             </a:r>
           </a:p>
         </p:txBody>
@@ -4330,6 +4385,7 @@
           <a:lstStyle xmlns:a="http://schemas.openxmlformats.org/drawingml/2006/main"/>
           <a:p xmlns:a="http://schemas.openxmlformats.org/drawingml/2006/main">
             <a:pPr algn="l">
+              <a:buNone/>
               <a:defRPr sz="1950" b="0">
                 <a:solidFill>
                   <a:srgbClr val="5E6B62"/>
@@ -4348,7 +4404,7 @@
                 <a:ea typeface="Arial"/>
                 <a:cs typeface="Arial"/>
               </a:rPr>
-              <a:t>Android nativo, DAT e Mock Device Kit — com segurança no centro da jornada.</a:t>
+              <a:t>Simulação comprovada; DAT e rota de áudio são o próximo teste no hardware.</a:t>
             </a:r>
           </a:p>
         </p:txBody>
@@ -4423,6 +4479,7 @@
           <a:lstStyle xmlns:a="http://schemas.openxmlformats.org/drawingml/2006/main"/>
           <a:p xmlns:a="http://schemas.openxmlformats.org/drawingml/2006/main">
             <a:pPr algn="l">
+              <a:buNone/>
               <a:defRPr sz="5400" b="1">
                 <a:solidFill>
                   <a:srgbClr val="174A2B"/>
@@ -4481,6 +4538,7 @@
           <a:lstStyle xmlns:a="http://schemas.openxmlformats.org/drawingml/2006/main"/>
           <a:p xmlns:a="http://schemas.openxmlformats.org/drawingml/2006/main">
             <a:pPr algn="l">
+              <a:buNone/>
               <a:defRPr sz="1950" b="1">
                 <a:solidFill>
                   <a:srgbClr val="111814"/>
@@ -4539,6 +4597,7 @@
           <a:lstStyle xmlns:a="http://schemas.openxmlformats.org/drawingml/2006/main"/>
           <a:p xmlns:a="http://schemas.openxmlformats.org/drawingml/2006/main">
             <a:pPr algn="l">
+              <a:buNone/>
               <a:defRPr sz="1575" b="0">
                 <a:solidFill>
                   <a:srgbClr val="5E6B62"/>
@@ -4557,7 +4616,7 @@
                 <a:ea typeface="Arial"/>
                 <a:cs typeface="Arial"/>
               </a:rPr>
-              <a:t>IA, câmera/mic, áudio, privacidade e bateria.</a:t>
+              <a:t>IA, câmera + voz, áudio, privacidade e bateria.</a:t>
             </a:r>
           </a:p>
         </p:txBody>
@@ -4632,6 +4691,7 @@
           <a:lstStyle xmlns:a="http://schemas.openxmlformats.org/drawingml/2006/main"/>
           <a:p xmlns:a="http://schemas.openxmlformats.org/drawingml/2006/main">
             <a:pPr algn="l">
+              <a:buNone/>
               <a:defRPr sz="5400" b="1">
                 <a:solidFill>
                   <a:srgbClr val="174A2B"/>
@@ -4690,6 +4750,7 @@
           <a:lstStyle xmlns:a="http://schemas.openxmlformats.org/drawingml/2006/main"/>
           <a:p xmlns:a="http://schemas.openxmlformats.org/drawingml/2006/main">
             <a:pPr algn="l">
+              <a:buNone/>
               <a:defRPr sz="1950" b="1">
                 <a:solidFill>
                   <a:srgbClr val="111814"/>
@@ -4748,6 +4809,7 @@
           <a:lstStyle xmlns:a="http://schemas.openxmlformats.org/drawingml/2006/main"/>
           <a:p xmlns:a="http://schemas.openxmlformats.org/drawingml/2006/main">
             <a:pPr algn="l">
+              <a:buNone/>
               <a:defRPr sz="1575" b="0">
                 <a:solidFill>
                   <a:srgbClr val="5E6B62"/>
@@ -4841,6 +4903,7 @@
           <a:lstStyle xmlns:a="http://schemas.openxmlformats.org/drawingml/2006/main"/>
           <a:p xmlns:a="http://schemas.openxmlformats.org/drawingml/2006/main">
             <a:pPr algn="l">
+              <a:buNone/>
               <a:defRPr sz="5400" b="1">
                 <a:solidFill>
                   <a:srgbClr val="174A2B"/>
@@ -4899,6 +4962,7 @@
           <a:lstStyle xmlns:a="http://schemas.openxmlformats.org/drawingml/2006/main"/>
           <a:p xmlns:a="http://schemas.openxmlformats.org/drawingml/2006/main">
             <a:pPr algn="l">
+              <a:buNone/>
               <a:defRPr sz="1950" b="1">
                 <a:solidFill>
                   <a:srgbClr val="111814"/>
@@ -4957,6 +5021,7 @@
           <a:lstStyle xmlns:a="http://schemas.openxmlformats.org/drawingml/2006/main"/>
           <a:p xmlns:a="http://schemas.openxmlformats.org/drawingml/2006/main">
             <a:pPr algn="l">
+              <a:buNone/>
               <a:defRPr sz="1575" b="0">
                 <a:solidFill>
                   <a:srgbClr val="5E6B62"/>
@@ -5015,6 +5080,7 @@
           <a:lstStyle xmlns:a="http://schemas.openxmlformats.org/drawingml/2006/main"/>
           <a:p xmlns:a="http://schemas.openxmlformats.org/drawingml/2006/main">
             <a:pPr algn="l">
+              <a:buNone/>
               <a:defRPr sz="2025" b="1">
                 <a:solidFill>
                   <a:srgbClr val="174A2B"/>
@@ -5033,7 +5099,7 @@
                 <a:ea typeface="Arial"/>
                 <a:cs typeface="Arial"/>
               </a:rPr>
-              <a:t>Nenhum movimento acontece sem confirmação por áudio.</a:t>
+              <a:t>ACCEPTED + Nav2 ativo + odometria mudou. ‘Cancelar’ = sem comando.</a:t>
             </a:r>
           </a:p>
         </p:txBody>
@@ -5073,6 +5139,7 @@
           <a:lstStyle xmlns:a="http://schemas.openxmlformats.org/drawingml/2006/main"/>
           <a:p xmlns:a="http://schemas.openxmlformats.org/drawingml/2006/main">
             <a:pPr algn="r">
+              <a:buNone/>
               <a:defRPr sz="1200" b="0">
                 <a:solidFill>
                   <a:srgbClr val="5E6B62"/>
@@ -5160,6 +5227,7 @@
           <a:lstStyle xmlns:a="http://schemas.openxmlformats.org/drawingml/2006/main"/>
           <a:p xmlns:a="http://schemas.openxmlformats.org/drawingml/2006/main">
             <a:pPr algn="l">
+              <a:buNone/>
               <a:defRPr sz="1650" b="1">
                 <a:solidFill>
                   <a:srgbClr val="2F7D4A"/>
@@ -5218,6 +5286,7 @@
           <a:lstStyle xmlns:a="http://schemas.openxmlformats.org/drawingml/2006/main"/>
           <a:p xmlns:a="http://schemas.openxmlformats.org/drawingml/2006/main">
             <a:pPr algn="l">
+              <a:buNone/>
               <a:defRPr sz="5250" b="1">
                 <a:solidFill>
                   <a:srgbClr val="111814"/>
@@ -5276,6 +5345,7 @@
           <a:lstStyle xmlns:a="http://schemas.openxmlformats.org/drawingml/2006/main"/>
           <a:p xmlns:a="http://schemas.openxmlformats.org/drawingml/2006/main">
             <a:pPr algn="l">
+              <a:buNone/>
               <a:defRPr sz="3300" b="1">
                 <a:solidFill>
                   <a:srgbClr val="174A2B"/>

</xml_diff>

<commit_message>
docs(pitch): detail local AI and safety evidence
</commit_message>
<xml_diff>
--- a/docs/pitch/Maestro-Agricola-Pitch.pptx
+++ b/docs/pitch/Maestro-Agricola-Pitch.pptx
@@ -2,18 +2,18 @@
 <file path=ppt/presentation.xml><?xml version="1.0" encoding="utf-8"?>
 <p:presentation xmlns:p="http://schemas.openxmlformats.org/presentationml/2006/main">
   <p:sldMasterIdLst>
-    <p:sldMasterId xmlns:r="http://schemas.openxmlformats.org/officeDocument/2006/relationships" id="2147483648" r:id="Rbd239dc8c01f4b8c"/>
+    <p:sldMasterId xmlns:r="http://schemas.openxmlformats.org/officeDocument/2006/relationships" id="2147483648" r:id="Rd391a0e4e9304b5a"/>
   </p:sldMasterIdLst>
   <p:notesMasterIdLst>
-    <p:notesMasterId xmlns:r="http://schemas.openxmlformats.org/officeDocument/2006/relationships" r:id="R159d68aa0a2c48e5"/>
+    <p:notesMasterId xmlns:r="http://schemas.openxmlformats.org/officeDocument/2006/relationships" r:id="Rb53865809c914c5e"/>
   </p:notesMasterIdLst>
   <p:sldIdLst>
-    <p:sldId xmlns:r="http://schemas.openxmlformats.org/officeDocument/2006/relationships" id="256" r:id="Ra164d11e08b94571"/>
-    <p:sldId xmlns:r="http://schemas.openxmlformats.org/officeDocument/2006/relationships" id="257" r:id="R216c4fc55b594a48"/>
-    <p:sldId xmlns:r="http://schemas.openxmlformats.org/officeDocument/2006/relationships" id="258" r:id="Rff0b452be7694d13"/>
-    <p:sldId xmlns:r="http://schemas.openxmlformats.org/officeDocument/2006/relationships" id="259" r:id="R07997ddcee574f1e"/>
-    <p:sldId xmlns:r="http://schemas.openxmlformats.org/officeDocument/2006/relationships" id="260" r:id="Ra2cf5352040f4227"/>
-    <p:sldId xmlns:r="http://schemas.openxmlformats.org/officeDocument/2006/relationships" id="261" r:id="R6c39c2f5257343e4"/>
+    <p:sldId xmlns:r="http://schemas.openxmlformats.org/officeDocument/2006/relationships" id="256" r:id="R3e43ce35b2bc404f"/>
+    <p:sldId xmlns:r="http://schemas.openxmlformats.org/officeDocument/2006/relationships" id="257" r:id="Rc95b6df5c60c492c"/>
+    <p:sldId xmlns:r="http://schemas.openxmlformats.org/officeDocument/2006/relationships" id="258" r:id="R8457384d6e2c4c82"/>
+    <p:sldId xmlns:r="http://schemas.openxmlformats.org/officeDocument/2006/relationships" id="259" r:id="Rb85f2b3dbd2a46fa"/>
+    <p:sldId xmlns:r="http://schemas.openxmlformats.org/officeDocument/2006/relationships" id="260" r:id="R441fb6f5f36249e3"/>
+    <p:sldId xmlns:r="http://schemas.openxmlformats.org/officeDocument/2006/relationships" id="261" r:id="Rd46c736e52d64292"/>
   </p:sldIdLst>
   <p:sldSz cx="12192000" cy="6858000"/>
   <p:notesSz cx="6858000" cy="9144000"/>
@@ -462,7 +462,7 @@
           </a:p>
           <a:p xmlns:a="http://schemas.openxmlformats.org/drawingml/2006/main">
             <a:r>
-              <a:t>- Versão Resumida — Maestro Agrícola, equipe AgroTurtles, 2026.</a:t>
+              <a:t>- docs/proposta/versao-resumida.md, equipe AgroTurtles, revisão de 18 ago. 2026.</a:t>
             </a:r>
           </a:p>
           <a:p xmlns:a="http://schemas.openxmlformats.org/drawingml/2006/main">
@@ -552,7 +552,7 @@
           </a:p>
           <a:p xmlns:a="http://schemas.openxmlformats.org/drawingml/2006/main">
             <a:r>
-              <a:t>- Versão Técnica — Maestro Agrícola, equipe AgroTurtles, 2026.</a:t>
+              <a:t>- docs/proposta/versao-tecnica.md, equipe AgroTurtles, revisão de 18 ago. 2026.</a:t>
             </a:r>
           </a:p>
         </p:txBody>
@@ -622,7 +622,7 @@
           <a:lstStyle xmlns:a="http://schemas.openxmlformats.org/drawingml/2006/main"/>
           <a:p xmlns:a="http://schemas.openxmlformats.org/drawingml/2006/main">
             <a:r>
-              <a:t>A jornada tem três ações. Olhar: um QR identifica o talhão três, associado a uma posição segura no mapa. Falar: o reconhecimento nativo transcreve “pulverizar esta área”, e uma IA pequena, local e restrita classifica a intenção. Confirmar: o sistema pergunta “pulverizar talhão três?”. Só o sim libera o JSON. Se houver ambiguidade ou o usuário disser “cancelar”, nenhum comando chega ao robô.</a:t>
+              <a:t>A jornada tem três ações. Olhar: uma placa legível e seu QR identificam o plot três, associado a uma pose segura. Falar: o reconhecimento nativo transcreve a voz; depois, um classificador softmax de 65 kilobytes, treinado com 96 frases, roda no celular e retorna pulverizar, confirmar, cancelar ou desconhecido. Se o operador disser “no plot três”, o ID falado também é validado. Confirmar: o Maestro repete o alvo. Abaixo de 40% de confiança, ou se voz e câmera discordarem, nada é enviado.</a:t>
             </a:r>
           </a:p>
           <a:p xmlns:a="http://schemas.openxmlformats.org/drawingml/2006/main">
@@ -637,12 +637,17 @@
           </a:p>
           <a:p xmlns:a="http://schemas.openxmlformats.org/drawingml/2006/main">
             <a:r>
+              <a:t>- shared/ai/intent_model.json e shared/ai/evaluation.json, equipe AgroTurtles, 18 ago. 2026.</a:t>
+            </a:r>
+          </a:p>
+          <a:p xmlns:a="http://schemas.openxmlformats.org/drawingml/2006/main">
+            <a:r>
+              <a:t>- shared/target/target_resolution_cases.json, equipe AgroTurtles, 18 ago. 2026.</a:t>
+            </a:r>
+          </a:p>
+          <a:p xmlns:a="http://schemas.openxmlformats.org/drawingml/2006/main">
+            <a:r>
               <a:t>- Meta Wearables DAT CameraAccess: https://github.com/facebook/meta-wearables-dat-android/tree/main/samples/CameraAccess</a:t>
-            </a:r>
-          </a:p>
-          <a:p xmlns:a="http://schemas.openxmlformats.org/drawingml/2006/main">
-            <a:r>
-              <a:t>- docs/mvp-spec.md e docs/submission/final-form.md, equipe AgroTurtles, 2026.</a:t>
             </a:r>
           </a:p>
         </p:txBody>
@@ -712,7 +717,7 @@
           <a:lstStyle xmlns:a="http://schemas.openxmlformats.org/drawingml/2006/main"/>
           <a:p xmlns:a="http://schemas.openxmlformats.org/drawingml/2006/main">
             <a:r>
-              <a:t>Por dentro, a câmera entra pelo DAT. Voz e TTS usam recursos nativos do celular e tentam a rota Bluetooth, com o telefone como fallback. Kotlin e Swift consomem a mesma IA local e o mesmo contrato. Após a confirmação, um JSON com validade curta chega ao bridge, que valida e entrega uma meta ao Nav2 no Gazebo. Como o DAT público não documenta pose ou IMU, o MVP usa QR mapeado e isola a integração real no adaptador de câmera.</a:t>
+              <a:t>Por dentro, a câmera entra pelo DAT. Voz e TTS usam recursos nativos do celular, com o telefone como fallback. Kotlin e Swift consomem a mesma IA, o mesmo catálogo de plots e o mesmo contrato. Após a confirmação, um JSON com validade curta chega ao bridge, que valida e entrega uma meta ao Nav2 no Gazebo. Como o DAT público não documenta pose ou IMU, o MVP usa um alvo mapeado; GPS do operador não vira destino do robô.</a:t>
             </a:r>
           </a:p>
           <a:p xmlns:a="http://schemas.openxmlformats.org/drawingml/2006/main">
@@ -738,6 +743,11 @@
           <a:p xmlns:a="http://schemas.openxmlformats.org/drawingml/2006/main">
             <a:r>
               <a:t>- A ausência de pose/IMU é uma inferência a partir das APIs públicas consultadas; validar novamente contra a versão do SDK usada no evento.</a:t>
+            </a:r>
+          </a:p>
+          <a:p xmlns:a="http://schemas.openxmlformats.org/drawingml/2006/main">
+            <a:r>
+              <a:t>- docs/architecture.md, equipe AgroTurtles, revisão de 18 ago. 2026.</a:t>
             </a:r>
           </a:p>
         </p:txBody>
@@ -807,7 +817,7 @@
           <a:lstStyle xmlns:a="http://schemas.openxmlformats.org/drawingml/2006/main"/>
           <a:p xmlns:a="http://schemas.openxmlformats.org/drawingml/2006/main">
             <a:r>
-              <a:t>Hoje já provamos o ciclo na simulação. O cliente enviou “pulverizar esta área”, recebeu ACCEPTED, o Nav2 ficou ativo e a odometria do TurtleBot mudou. “Cancelar” foi recusado localmente, sem movimento. O desenho cobre os cinco pilares: IA, câmera e voz, saída por áudio, privacidade e eficiência por captura sob demanda. O próximo passo é compilar nos dois aparelhos e validar DAT, latência, bateria e rota Bluetooth com os óculos reais.</a:t>
+              <a:t>Hoje já provamos três sinais: a placa completa foi decodificada como plot três; a política local obteve 15 de 16 acertos operacionais; e o cliente recebeu ACCEPTED, ativou o Nav2 e mudou a odometria do TurtleBot. “Cancelar” foi recusado sem movimento. O desenho cobre IA, câmera e voz, áudio, privacidade e captura sob demanda. O próximo gate é compilar nos dois aparelhos e validar DAT, latência, bateria e rota Bluetooth com os óculos reais.</a:t>
             </a:r>
           </a:p>
           <a:p xmlns:a="http://schemas.openxmlformats.org/drawingml/2006/main">
@@ -822,17 +832,17 @@
           </a:p>
           <a:p xmlns:a="http://schemas.openxmlformats.org/drawingml/2006/main">
             <a:r>
-              <a:t>- docs/tasks/submission-readiness.md: execução local de 18 ago. 2026.</a:t>
-            </a:r>
-          </a:p>
-          <a:p xmlns:a="http://schemas.openxmlformats.org/drawingml/2006/main">
-            <a:r>
-              <a:t>- docs/testing.md e saída de make demo: ACCEPTED, Nav2 ativo e odometria alterada.</a:t>
-            </a:r>
-          </a:p>
-          <a:p xmlns:a="http://schemas.openxmlformats.org/drawingml/2006/main">
-            <a:r>
-              <a:t>- Palestras finais do CEIA analisadas em docs/references/ceia-materials.md.</a:t>
+              <a:t>- tests/test_qr_target_detector.py e make vision-smoke, equipe AgroTurtles, 18 ago. 2026.</a:t>
+            </a:r>
+          </a:p>
+          <a:p xmlns:a="http://schemas.openxmlformats.org/drawingml/2006/main">
+            <a:r>
+              <a:t>- shared/ai/evaluation.json, conjunto separado de 16 frases, equipe AgroTurtles, 18 ago. 2026.</a:t>
+            </a:r>
+          </a:p>
+          <a:p xmlns:a="http://schemas.openxmlformats.org/drawingml/2006/main">
+            <a:r>
+              <a:t>- docs/testing.md e docs/tasks/submission-readiness.md: ACCEPTED, Nav2 ativo e odometria alterada, execução de 18 ago. 2026.</a:t>
             </a:r>
           </a:p>
         </p:txBody>
@@ -902,7 +912,7 @@
           <a:lstStyle xmlns:a="http://schemas.openxmlformats.org/drawingml/2006/main"/>
           <a:p xmlns:a="http://schemas.openxmlformats.org/drawingml/2006/main">
             <a:r>
-              <a:t>A John Deere mostra o valor de acompanhar máquinas pelo celular; a Meta mostra os óculos como interface multimodal. O Maestro conecta esses mundos com protocolo aberto, confirmação obrigatória e ROS 2, sem se prender a um fabricante. O futuro do campo não precisa de mais uma tela. Precisa entender alvo, intenção e segurança. Maestro Agrícola: olhe, fale, confirme.</a:t>
+              <a:t>O Maestro conecta interface multimodal e robótica com protocolo aberto, confirmação obrigatória e ROS 2, sem se prender a um fabricante. O futuro do campo não precisa de mais uma tela. Precisa entender alvo, intenção e segurança. Maestro Agrícola: olhe, fale, confirme.</a:t>
             </a:r>
           </a:p>
           <a:p xmlns:a="http://schemas.openxmlformats.org/drawingml/2006/main">
@@ -917,17 +927,7 @@
           </a:p>
           <a:p xmlns:a="http://schemas.openxmlformats.org/drawingml/2006/main">
             <a:r>
-              <a:t>- Meta AI: https://ai.meta.com/meta-ai/</a:t>
-            </a:r>
-          </a:p>
-          <a:p xmlns:a="http://schemas.openxmlformats.org/drawingml/2006/main">
-            <a:r>
-              <a:t>- John Deere Operations Center: https://www.deere.com/en/technology-products/precision-ag-technology/operations-center/</a:t>
-            </a:r>
-          </a:p>
-          <a:p xmlns:a="http://schemas.openxmlformats.org/drawingml/2006/main">
-            <a:r>
-              <a:t>- Síntese e diferenciação em docs/submission/final-form.md.</a:t>
+              <a:t>- docs/submission/final-form.md, equipe AgroTurtles, revisão de 18 ago. 2026.</a:t>
             </a:r>
           </a:p>
         </p:txBody>
@@ -995,7 +995,7 @@
   </p:cSld>
   <p:clrMap bg1="lt1" tx1="dk1" bg2="lt2" tx2="dk2" accent1="accent1" accent2="accent2" accent3="accent3" accent4="accent4" accent5="accent5" accent6="accent6" hlink="hlink" folHlink="folHlink"/>
   <p:sldLayoutIdLst>
-    <p:sldLayoutId xmlns:r="http://schemas.openxmlformats.org/officeDocument/2006/relationships" id="2147483649" r:id="Rc6602b5e9eec4503"/>
+    <p:sldLayoutId xmlns:r="http://schemas.openxmlformats.org/officeDocument/2006/relationships" id="2147483649" r:id="Rca213d8ef7494ca9"/>
   </p:sldLayoutIdLst>
   <p:txStyles>
     <p:titleStyle>
@@ -1817,7 +1817,7 @@
           <p:nvPr/>
         </p:nvPicPr>
         <p:blipFill>
-          <a:blip xmlns:r="http://schemas.openxmlformats.org/officeDocument/2006/relationships" xmlns:a="http://schemas.openxmlformats.org/drawingml/2006/main" r:embed="Rd889c7481aeb4128"/>
+          <a:blip xmlns:r="http://schemas.openxmlformats.org/officeDocument/2006/relationships" xmlns:a="http://schemas.openxmlformats.org/drawingml/2006/main" r:embed="R7ae2d20258b742f9"/>
           <a:srcRect xmlns:a="http://schemas.openxmlformats.org/drawingml/2006/main" l="1105" t="0" r="1105" b="0"/>
           <a:stretch xmlns:a="http://schemas.openxmlformats.org/drawingml/2006/main">
             <a:fillRect l="0" t="0" r="0" b="0"/>
@@ -2540,7 +2540,8 @@
                 <a:ea typeface="Arial"/>
                 <a:cs typeface="Arial"/>
               </a:rPr>
-              <a:t>O QR identifica o talhão centralizado.</a:t>
+              <a:t>Placa + QR resolvem o plot.
+O ID falado também é validado.</a:t>
             </a:r>
           </a:p>
         </p:txBody>
@@ -2693,7 +2694,9 @@
                 <a:ea typeface="Arial"/>
                 <a:cs typeface="Arial"/>
               </a:rPr>
-              <a:t>A voz vira uma intenção local e restrita.</a:t>
+              <a:t>Softmax local
+65 KB · 4 intenções
+limiar 0,40</a:t>
             </a:r>
           </a:p>
         </p:txBody>
@@ -2938,7 +2941,7 @@
                 <a:ea typeface="Arial"/>
                 <a:cs typeface="Arial"/>
               </a:rPr>
-              <a:t>Falha segura: ambiguidade ou ‘cancelar’ = nenhum comando.</a:t>
+              <a:t>Voz ≠ câmera ou falta de confirmação = nenhum comando.</a:t>
             </a:r>
           </a:p>
         </p:txBody>
@@ -3386,7 +3389,7 @@
                 <a:ea typeface="Arial"/>
                 <a:cs typeface="Arial"/>
               </a:rPr>
-              <a:t>áudio do sistema</a:t>
+              <a:t>placa + QR</a:t>
             </a:r>
           </a:p>
           <a:p xmlns:a="http://schemas.openxmlformats.org/drawingml/2006/main">
@@ -3410,7 +3413,7 @@
                 <a:ea typeface="Arial"/>
                 <a:cs typeface="Arial"/>
               </a:rPr>
-              <a:t>rota a validar</a:t>
+              <a:t>voz/TTS nativos</a:t>
             </a:r>
           </a:p>
         </p:txBody>
@@ -3618,7 +3621,7 @@
                 <a:ea typeface="Arial"/>
                 <a:cs typeface="Arial"/>
               </a:rPr>
-              <a:t>IA local</a:t>
+              <a:t>softmax · 65 KB</a:t>
             </a:r>
           </a:p>
           <a:p xmlns:a="http://schemas.openxmlformats.org/drawingml/2006/main">
@@ -4198,7 +4201,7 @@
                 <a:ea typeface="Arial"/>
                 <a:cs typeface="Arial"/>
               </a:rPr>
-              <a:t>MVP: QR mapeado — sem depender de pose/IMU que o DAT público não expõe.</a:t>
+              <a:t>Alvo visual + ID falado; se discordarem, nada é enviado. GPS não vira destino.</a:t>
             </a:r>
           </a:p>
         </p:txBody>
@@ -4404,7 +4407,7 @@
                 <a:ea typeface="Arial"/>
                 <a:cs typeface="Arial"/>
               </a:rPr>
-              <a:t>Simulação comprovada; DAT e rota de áudio são o próximo teste no hardware.</a:t>
+              <a:t>Três sinais reproduzíveis; o próximo gate é o hardware real.</a:t>
             </a:r>
           </a:p>
         </p:txBody>
@@ -4498,7 +4501,7 @@
                 <a:ea typeface="Arial"/>
                 <a:cs typeface="Arial"/>
               </a:rPr>
-              <a:t>5/5</a:t>
+              <a:t>QR</a:t>
             </a:r>
           </a:p>
         </p:txBody>
@@ -4557,7 +4560,7 @@
                 <a:ea typeface="Arial"/>
                 <a:cs typeface="Arial"/>
               </a:rPr>
-              <a:t>checkpoints</a:t>
+              <a:t>plot-03 detectado</a:t>
             </a:r>
           </a:p>
         </p:txBody>
@@ -4616,7 +4619,7 @@
                 <a:ea typeface="Arial"/>
                 <a:cs typeface="Arial"/>
               </a:rPr>
-              <a:t>IA, câmera + voz, áudio, privacidade e bateria.</a:t>
+              <a:t>Placa completa decodificada localmente.</a:t>
             </a:r>
           </a:p>
         </p:txBody>
@@ -4710,7 +4713,7 @@
                 <a:ea typeface="Arial"/>
                 <a:cs typeface="Arial"/>
               </a:rPr>
-              <a:t>1</a:t>
+              <a:t>15/16</a:t>
             </a:r>
           </a:p>
         </p:txBody>
@@ -4769,7 +4772,7 @@
                 <a:ea typeface="Arial"/>
                 <a:cs typeface="Arial"/>
               </a:rPr>
-              <a:t>captura por ação</a:t>
+              <a:t>IA operacional</a:t>
             </a:r>
           </a:p>
         </p:txBody>
@@ -4828,7 +4831,7 @@
                 <a:ea typeface="Arial"/>
                 <a:cs typeface="Arial"/>
               </a:rPr>
-              <a:t>Processamento sob demanda, não gravação contínua.</a:t>
+              <a:t>96 frases; a restante virou UNKNOWN.</a:t>
             </a:r>
           </a:p>
         </p:txBody>
@@ -4922,7 +4925,7 @@
                 <a:ea typeface="Arial"/>
                 <a:cs typeface="Arial"/>
               </a:rPr>
-              <a:t>0</a:t>
+              <a:t>ROS 2</a:t>
             </a:r>
           </a:p>
         </p:txBody>
@@ -4981,7 +4984,7 @@
                 <a:ea typeface="Arial"/>
                 <a:cs typeface="Arial"/>
               </a:rPr>
-              <a:t>mídia salva</a:t>
+              <a:t>movimento provado</a:t>
             </a:r>
           </a:p>
         </p:txBody>
@@ -5040,7 +5043,7 @@
                 <a:ea typeface="Arial"/>
                 <a:cs typeface="Arial"/>
               </a:rPr>
-              <a:t>Frame descartado depois de resolver o alvo.</a:t>
+              <a:t>ACCEPTED + Nav2 ativo + odometria mudou.</a:t>
             </a:r>
           </a:p>
         </p:txBody>
@@ -5099,7 +5102,7 @@
                 <a:ea typeface="Arial"/>
                 <a:cs typeface="Arial"/>
               </a:rPr>
-              <a:t>ACCEPTED + Nav2 ativo + odometria mudou. ‘Cancelar’ = sem comando.</a:t>
+              <a:t>Voz ≠ câmera, ‘cancelar’ ou falta de confirmação = sem comando.</a:t>
             </a:r>
           </a:p>
         </p:txBody>

</xml_diff>

<commit_message>
docs(pitch): apply AgroTurtles visual identity
</commit_message>
<xml_diff>
--- a/docs/pitch/Maestro-Agricola-Pitch.pptx
+++ b/docs/pitch/Maestro-Agricola-Pitch.pptx
@@ -2,18 +2,18 @@
 <file path=ppt/presentation.xml><?xml version="1.0" encoding="utf-8"?>
 <p:presentation xmlns:p="http://schemas.openxmlformats.org/presentationml/2006/main">
   <p:sldMasterIdLst>
-    <p:sldMasterId xmlns:r="http://schemas.openxmlformats.org/officeDocument/2006/relationships" id="2147483648" r:id="Rd391a0e4e9304b5a"/>
+    <p:sldMasterId xmlns:r="http://schemas.openxmlformats.org/officeDocument/2006/relationships" id="2147483648" r:id="Rd92d0b25ee234fb8"/>
   </p:sldMasterIdLst>
   <p:notesMasterIdLst>
-    <p:notesMasterId xmlns:r="http://schemas.openxmlformats.org/officeDocument/2006/relationships" r:id="Rb53865809c914c5e"/>
+    <p:notesMasterId xmlns:r="http://schemas.openxmlformats.org/officeDocument/2006/relationships" r:id="R7e78c799b439469e"/>
   </p:notesMasterIdLst>
   <p:sldIdLst>
-    <p:sldId xmlns:r="http://schemas.openxmlformats.org/officeDocument/2006/relationships" id="256" r:id="R3e43ce35b2bc404f"/>
-    <p:sldId xmlns:r="http://schemas.openxmlformats.org/officeDocument/2006/relationships" id="257" r:id="Rc95b6df5c60c492c"/>
-    <p:sldId xmlns:r="http://schemas.openxmlformats.org/officeDocument/2006/relationships" id="258" r:id="R8457384d6e2c4c82"/>
-    <p:sldId xmlns:r="http://schemas.openxmlformats.org/officeDocument/2006/relationships" id="259" r:id="Rb85f2b3dbd2a46fa"/>
-    <p:sldId xmlns:r="http://schemas.openxmlformats.org/officeDocument/2006/relationships" id="260" r:id="R441fb6f5f36249e3"/>
-    <p:sldId xmlns:r="http://schemas.openxmlformats.org/officeDocument/2006/relationships" id="261" r:id="Rd46c736e52d64292"/>
+    <p:sldId xmlns:r="http://schemas.openxmlformats.org/officeDocument/2006/relationships" id="256" r:id="Rb3645c3853d84365"/>
+    <p:sldId xmlns:r="http://schemas.openxmlformats.org/officeDocument/2006/relationships" id="257" r:id="Rb6df3376c634478c"/>
+    <p:sldId xmlns:r="http://schemas.openxmlformats.org/officeDocument/2006/relationships" id="258" r:id="R74f5dda3f67249f8"/>
+    <p:sldId xmlns:r="http://schemas.openxmlformats.org/officeDocument/2006/relationships" id="259" r:id="R0b69c123912a40d3"/>
+    <p:sldId xmlns:r="http://schemas.openxmlformats.org/officeDocument/2006/relationships" id="260" r:id="R155ea3713f1e4dfe"/>
+    <p:sldId xmlns:r="http://schemas.openxmlformats.org/officeDocument/2006/relationships" id="261" r:id="Rc19b7a42479b487f"/>
   </p:sldIdLst>
   <p:sldSz cx="12192000" cy="6858000"/>
   <p:notesSz cx="6858000" cy="9144000"/>
@@ -470,6 +470,11 @@
               <a:t>- Imagem original gerada para esta apresentação com OpenAI Image Generation em 16 ago. 2026; sem fotografia externa.</a:t>
             </a:r>
           </a:p>
+          <a:p xmlns:a="http://schemas.openxmlformats.org/drawingml/2006/main">
+            <a:r>
+              <a:t>- Identidade visual e logos: assets/brand, equipe AgroTurtles, 18 ago. 2026.</a:t>
+            </a:r>
+          </a:p>
         </p:txBody>
       </p:sp>
       <p:sp>
@@ -555,6 +560,11 @@
               <a:t>- docs/proposta/versao-tecnica.md, equipe AgroTurtles, revisão de 18 ago. 2026.</a:t>
             </a:r>
           </a:p>
+          <a:p xmlns:a="http://schemas.openxmlformats.org/drawingml/2006/main">
+            <a:r>
+              <a:t>- Identidade visual e logos: assets/brand, equipe AgroTurtles, 18 ago. 2026.</a:t>
+            </a:r>
+          </a:p>
         </p:txBody>
       </p:sp>
       <p:sp>
@@ -650,6 +660,11 @@
               <a:t>- Meta Wearables DAT CameraAccess: https://github.com/facebook/meta-wearables-dat-android/tree/main/samples/CameraAccess</a:t>
             </a:r>
           </a:p>
+          <a:p xmlns:a="http://schemas.openxmlformats.org/drawingml/2006/main">
+            <a:r>
+              <a:t>- Identidade visual e logos: assets/brand, equipe AgroTurtles, 18 ago. 2026.</a:t>
+            </a:r>
+          </a:p>
         </p:txBody>
       </p:sp>
       <p:sp>
@@ -750,6 +765,11 @@
               <a:t>- docs/architecture.md, equipe AgroTurtles, revisão de 18 ago. 2026.</a:t>
             </a:r>
           </a:p>
+          <a:p xmlns:a="http://schemas.openxmlformats.org/drawingml/2006/main">
+            <a:r>
+              <a:t>- Identidade visual e logos: assets/brand, equipe AgroTurtles, 18 ago. 2026.</a:t>
+            </a:r>
+          </a:p>
         </p:txBody>
       </p:sp>
       <p:sp>
@@ -845,6 +865,11 @@
               <a:t>- docs/testing.md e docs/tasks/submission-readiness.md: ACCEPTED, Nav2 ativo e odometria alterada, execução de 18 ago. 2026.</a:t>
             </a:r>
           </a:p>
+          <a:p xmlns:a="http://schemas.openxmlformats.org/drawingml/2006/main">
+            <a:r>
+              <a:t>- Identidade visual e logos: assets/brand, equipe AgroTurtles, 18 ago. 2026.</a:t>
+            </a:r>
+          </a:p>
         </p:txBody>
       </p:sp>
       <p:sp>
@@ -928,6 +953,11 @@
           <a:p xmlns:a="http://schemas.openxmlformats.org/drawingml/2006/main">
             <a:r>
               <a:t>- docs/submission/final-form.md, equipe AgroTurtles, revisão de 18 ago. 2026.</a:t>
+            </a:r>
+          </a:p>
+          <a:p xmlns:a="http://schemas.openxmlformats.org/drawingml/2006/main">
+            <a:r>
+              <a:t>- Identidade visual e logos: assets/brand, equipe AgroTurtles, 18 ago. 2026.</a:t>
             </a:r>
           </a:p>
         </p:txBody>
@@ -995,7 +1025,7 @@
   </p:cSld>
   <p:clrMap bg1="lt1" tx1="dk1" bg2="lt2" tx2="dk2" accent1="accent1" accent2="accent2" accent3="accent3" accent4="accent4" accent5="accent5" accent6="accent6" hlink="hlink" folHlink="folHlink"/>
   <p:sldLayoutIdLst>
-    <p:sldLayoutId xmlns:r="http://schemas.openxmlformats.org/officeDocument/2006/relationships" id="2147483649" r:id="Rca213d8ef7494ca9"/>
+    <p:sldLayoutId xmlns:r="http://schemas.openxmlformats.org/officeDocument/2006/relationships" id="2147483649" r:id="R657de1ff0ad644bb"/>
   </p:sldLayoutIdLst>
   <p:txStyles>
     <p:titleStyle>
@@ -1564,7 +1594,7 @@
             <a:avLst/>
           </a:prstGeom>
           <a:solidFill xmlns:a="http://schemas.openxmlformats.org/drawingml/2006/main">
-            <a:srgbClr val="2F7D4A"/>
+            <a:srgbClr val="FCC931"/>
           </a:solidFill>
           <a:ln xmlns:a="http://schemas.openxmlformats.org/drawingml/2006/main" w="0">
             <a:noFill/>
@@ -1620,11 +1650,11 @@
             <a:r>
               <a:rPr sz="5700" b="1">
                 <a:solidFill>
-                  <a:srgbClr val="111814"/>
-                </a:solidFill>
-                <a:latin typeface="Arial"/>
-                <a:ea typeface="Arial"/>
-                <a:cs typeface="Arial"/>
+                  <a:srgbClr val="3C4C1E"/>
+                </a:solidFill>
+                <a:latin typeface="League Spartan"/>
+                <a:ea typeface="League Spartan"/>
+                <a:cs typeface="League Spartan"/>
               </a:rPr>
               <a:t>Maestro Agrícola</a:t>
             </a:r>
@@ -1679,11 +1709,11 @@
             <a:r>
               <a:rPr sz="3600" b="1">
                 <a:solidFill>
-                  <a:srgbClr val="174A2B"/>
-                </a:solidFill>
-                <a:latin typeface="Arial"/>
-                <a:ea typeface="Arial"/>
-                <a:cs typeface="Arial"/>
+                  <a:srgbClr val="0F3C65"/>
+                </a:solidFill>
+                <a:latin typeface="League Spartan"/>
+                <a:ea typeface="League Spartan"/>
+                <a:cs typeface="League Spartan"/>
               </a:rPr>
               <a:t>Olhe. Fale. Confirme.</a:t>
             </a:r>
@@ -1738,72 +1768,13 @@
             <a:r>
               <a:rPr sz="2100" b="0">
                 <a:solidFill>
-                  <a:srgbClr val="5E6B62"/>
-                </a:solidFill>
-                <a:latin typeface="Arial"/>
-                <a:ea typeface="Arial"/>
-                <a:cs typeface="Arial"/>
+                  <a:srgbClr val="0F3C65"/>
+                </a:solidFill>
+                <a:latin typeface="League Spartan"/>
+                <a:ea typeface="League Spartan"/>
+                <a:cs typeface="League Spartan"/>
               </a:rPr>
               <a:t>Uma interface hands-free para transformar intenção humana em ação segura no campo.</a:t>
-            </a:r>
-          </a:p>
-        </p:txBody>
-      </p:sp>
-      <p:sp>
-        <p:nvSpPr>
-          <p:cNvPr id="5" name="cover-team">
-            <a:extLst xmlns:a="http://schemas.openxmlformats.org/drawingml/2006/main">
-              <a:ext uri="{FF2B5EF4-FFF2-40B4-BE49-F238E27FC236}">
-                <a16:creationId xmlns:a16="http://schemas.microsoft.com/office/drawing/2014/main" id="{94CE3902-D9DF-43DE-A8F5-26D9B306C0AE}"/>
-              </a:ext>
-            </a:extLst>
-          </p:cNvPr>
-          <p:cNvSpPr>
-            <a:spLocks xmlns:a="http://schemas.openxmlformats.org/drawingml/2006/main" noGrp="1"/>
-          </p:cNvSpPr>
-          <p:nvPr/>
-        </p:nvSpPr>
-        <p:spPr>
-          <a:xfrm xmlns:a="http://schemas.openxmlformats.org/drawingml/2006/main">
-            <a:off x="457200" y="5619750"/>
-            <a:ext cx="4953000" cy="304800"/>
-          </a:xfrm>
-          <a:prstGeom xmlns:a="http://schemas.openxmlformats.org/drawingml/2006/main" prst="rect">
-            <a:avLst/>
-          </a:prstGeom>
-          <a:noFill xmlns:a="http://schemas.openxmlformats.org/drawingml/2006/main"/>
-          <a:ln xmlns:a="http://schemas.openxmlformats.org/drawingml/2006/main" w="0">
-            <a:noFill/>
-            <a:prstDash val="solid"/>
-          </a:ln>
-        </p:spPr>
-        <p:txBody>
-          <a:bodyPr xmlns:a="http://schemas.openxmlformats.org/drawingml/2006/main" anchor="t">
-            <a:noAutofit/>
-          </a:bodyPr>
-          <a:lstStyle xmlns:a="http://schemas.openxmlformats.org/drawingml/2006/main"/>
-          <a:p xmlns:a="http://schemas.openxmlformats.org/drawingml/2006/main">
-            <a:pPr algn="l">
-              <a:buNone/>
-              <a:defRPr sz="1500" b="1">
-                <a:solidFill>
-                  <a:srgbClr val="5E6B62"/>
-                </a:solidFill>
-                <a:latin typeface="Arial"/>
-                <a:ea typeface="Arial"/>
-                <a:cs typeface="Arial"/>
-              </a:defRPr>
-            </a:pPr>
-            <a:r>
-              <a:rPr sz="1500" b="1">
-                <a:solidFill>
-                  <a:srgbClr val="5E6B62"/>
-                </a:solidFill>
-                <a:latin typeface="Arial"/>
-                <a:ea typeface="Arial"/>
-                <a:cs typeface="Arial"/>
-              </a:rPr>
-              <a:t>AGROTURTLES  •  AI GLASSES BRASIL 2026</a:t>
             </a:r>
           </a:p>
         </p:txBody>
@@ -1817,7 +1788,7 @@
           <p:nvPr/>
         </p:nvPicPr>
         <p:blipFill>
-          <a:blip xmlns:r="http://schemas.openxmlformats.org/officeDocument/2006/relationships" xmlns:a="http://schemas.openxmlformats.org/drawingml/2006/main" r:embed="R7ae2d20258b742f9"/>
+          <a:blip xmlns:r="http://schemas.openxmlformats.org/officeDocument/2006/relationships" xmlns:a="http://schemas.openxmlformats.org/drawingml/2006/main" r:embed="R991b6c40bc614906"/>
           <a:srcRect xmlns:a="http://schemas.openxmlformats.org/drawingml/2006/main" l="1105" t="0" r="1105" b="0"/>
           <a:stretch xmlns:a="http://schemas.openxmlformats.org/drawingml/2006/main">
             <a:fillRect l="0" t="0" r="0" b="0"/>
@@ -1883,17 +1854,39 @@
             <a:r>
               <a:rPr sz="1200" b="0">
                 <a:solidFill>
-                  <a:srgbClr val="5E6B62"/>
-                </a:solidFill>
-                <a:latin typeface="Arial"/>
-                <a:ea typeface="Arial"/>
-                <a:cs typeface="Arial"/>
+                  <a:srgbClr val="0F3C65"/>
+                </a:solidFill>
+                <a:latin typeface="League Spartan"/>
+                <a:ea typeface="League Spartan"/>
+                <a:cs typeface="League Spartan"/>
               </a:rPr>
               <a:t>01</a:t>
             </a:r>
           </a:p>
         </p:txBody>
       </p:sp>
+      <p:pic>
+        <p:nvPicPr>
+          <p:cNvPr id="17" name=""/>
+          <p:cNvPicPr>
+            <a:picLocks xmlns:a="http://schemas.openxmlformats.org/drawingml/2006/main" noChangeAspect="1"/>
+          </p:cNvPicPr>
+          <p:nvPr/>
+        </p:nvPicPr>
+        <p:blipFill>
+          <a:blip xmlns:r="http://schemas.openxmlformats.org/officeDocument/2006/relationships" xmlns:a="http://schemas.openxmlformats.org/drawingml/2006/main" r:embed="R069840e8eb714cb4"/>
+          <a:stretch xmlns:a="http://schemas.openxmlformats.org/drawingml/2006/main"/>
+        </p:blipFill>
+        <p:spPr>
+          <a:xfrm xmlns:a="http://schemas.openxmlformats.org/drawingml/2006/main">
+            <a:off x="462958" y="4857750"/>
+            <a:ext cx="4941484" cy="1381125"/>
+          </a:xfrm>
+          <a:prstGeom xmlns:a="http://schemas.openxmlformats.org/drawingml/2006/main" prst="rect">
+            <a:avLst/>
+          </a:prstGeom>
+        </p:spPr>
+      </p:pic>
     </p:spTree>
     <p:extLst>
       <p:ext uri="{BB962C8B-B14F-4D97-AF65-F5344CB8AC3E}">
@@ -1971,11 +1964,11 @@
             <a:r>
               <a:rPr sz="1500" b="1">
                 <a:solidFill>
-                  <a:srgbClr val="2F7D4A"/>
-                </a:solidFill>
-                <a:latin typeface="Arial"/>
-                <a:ea typeface="Arial"/>
-                <a:cs typeface="Arial"/>
+                  <a:srgbClr val="0F3C65"/>
+                </a:solidFill>
+                <a:latin typeface="League Spartan"/>
+                <a:ea typeface="League Spartan"/>
+                <a:cs typeface="League Spartan"/>
               </a:rPr>
               <a:t>O PROBLEMA</a:t>
             </a:r>
@@ -2030,11 +2023,11 @@
             <a:r>
               <a:rPr sz="5550" b="1">
                 <a:solidFill>
-                  <a:srgbClr val="111814"/>
-                </a:solidFill>
-                <a:latin typeface="Arial"/>
-                <a:ea typeface="Arial"/>
-                <a:cs typeface="Arial"/>
+                  <a:srgbClr val="3C4C1E"/>
+                </a:solidFill>
+                <a:latin typeface="League Spartan"/>
+                <a:ea typeface="League Spartan"/>
+                <a:cs typeface="League Spartan"/>
               </a:rPr>
               <a:t>A máquina é autônoma.</a:t>
             </a:r>
@@ -2054,11 +2047,11 @@
             <a:r>
               <a:rPr sz="5550" b="1">
                 <a:solidFill>
-                  <a:srgbClr val="111814"/>
-                </a:solidFill>
-                <a:latin typeface="Arial"/>
-                <a:ea typeface="Arial"/>
-                <a:cs typeface="Arial"/>
+                  <a:srgbClr val="3C4C1E"/>
+                </a:solidFill>
+                <a:latin typeface="League Spartan"/>
+                <a:ea typeface="League Spartan"/>
+                <a:cs typeface="League Spartan"/>
               </a:rPr>
               <a:t>A interface ainda não.</a:t>
             </a:r>
@@ -2088,7 +2081,7 @@
             <a:avLst/>
           </a:prstGeom>
           <a:solidFill xmlns:a="http://schemas.openxmlformats.org/drawingml/2006/main">
-            <a:srgbClr val="2F7D4A"/>
+            <a:srgbClr val="FCC931"/>
           </a:solidFill>
           <a:ln xmlns:a="http://schemas.openxmlformats.org/drawingml/2006/main" w="0">
             <a:noFill/>
@@ -2144,11 +2137,11 @@
             <a:r>
               <a:rPr sz="2100" b="0">
                 <a:solidFill>
-                  <a:srgbClr val="5E6B62"/>
-                </a:solidFill>
-                <a:latin typeface="Arial"/>
-                <a:ea typeface="Arial"/>
-                <a:cs typeface="Arial"/>
+                  <a:srgbClr val="0F3C65"/>
+                </a:solidFill>
+                <a:latin typeface="League Spartan"/>
+                <a:ea typeface="League Spartan"/>
+                <a:cs typeface="League Spartan"/>
               </a:rPr>
               <a:t>Parar o trabalho  →  limpar as mãos  →  abrir uma tela  →  reprogramar a rota</a:t>
             </a:r>
@@ -2203,76 +2196,39 @@
             <a:r>
               <a:rPr sz="1800" b="1">
                 <a:solidFill>
-                  <a:srgbClr val="174A2B"/>
-                </a:solidFill>
-                <a:latin typeface="Arial"/>
-                <a:ea typeface="Arial"/>
-                <a:cs typeface="Arial"/>
+                  <a:srgbClr val="3C4C1E"/>
+                </a:solidFill>
+                <a:latin typeface="League Spartan"/>
+                <a:ea typeface="League Spartan"/>
+                <a:cs typeface="League Spartan"/>
               </a:rPr>
               <a:t>No sol, na poeira e no ritmo da operação.</a:t>
             </a:r>
           </a:p>
         </p:txBody>
       </p:sp>
-      <p:sp>
-        <p:nvSpPr>
-          <p:cNvPr id="6" name="footer-2">
-            <a:extLst xmlns:a="http://schemas.openxmlformats.org/drawingml/2006/main">
-              <a:ext uri="{FF2B5EF4-FFF2-40B4-BE49-F238E27FC236}">
-                <a16:creationId xmlns:a16="http://schemas.microsoft.com/office/drawing/2014/main" id="{F74CB339-A2A7-4577-8C40-BA89E4AFA97E}"/>
-              </a:ext>
-            </a:extLst>
-          </p:cNvPr>
-          <p:cNvSpPr>
-            <a:spLocks xmlns:a="http://schemas.openxmlformats.org/drawingml/2006/main" noGrp="1"/>
-          </p:cNvSpPr>
-          <p:nvPr/>
-        </p:nvSpPr>
-        <p:spPr>
-          <a:xfrm xmlns:a="http://schemas.openxmlformats.org/drawingml/2006/main">
-            <a:off x="11334750" y="6334125"/>
-            <a:ext cx="457200" cy="209550"/>
-          </a:xfrm>
-          <a:prstGeom xmlns:a="http://schemas.openxmlformats.org/drawingml/2006/main" prst="rect">
-            <a:avLst/>
-          </a:prstGeom>
-          <a:noFill xmlns:a="http://schemas.openxmlformats.org/drawingml/2006/main"/>
-          <a:ln xmlns:a="http://schemas.openxmlformats.org/drawingml/2006/main" w="0">
-            <a:noFill/>
-            <a:prstDash val="solid"/>
-          </a:ln>
-        </p:spPr>
-        <p:txBody>
-          <a:bodyPr xmlns:a="http://schemas.openxmlformats.org/drawingml/2006/main" anchor="b">
-            <a:noAutofit/>
-          </a:bodyPr>
-          <a:lstStyle xmlns:a="http://schemas.openxmlformats.org/drawingml/2006/main"/>
-          <a:p xmlns:a="http://schemas.openxmlformats.org/drawingml/2006/main">
-            <a:pPr algn="r">
-              <a:buNone/>
-              <a:defRPr sz="1200" b="0">
-                <a:solidFill>
-                  <a:srgbClr val="5E6B62"/>
-                </a:solidFill>
-                <a:latin typeface="Arial"/>
-                <a:ea typeface="Arial"/>
-                <a:cs typeface="Arial"/>
-              </a:defRPr>
-            </a:pPr>
-            <a:r>
-              <a:rPr sz="1200" b="0">
-                <a:solidFill>
-                  <a:srgbClr val="5E6B62"/>
-                </a:solidFill>
-                <a:latin typeface="Arial"/>
-                <a:ea typeface="Arial"/>
-                <a:cs typeface="Arial"/>
-              </a:rPr>
-              <a:t>02</a:t>
-            </a:r>
-          </a:p>
-        </p:txBody>
-      </p:sp>
+      <p:pic>
+        <p:nvPicPr>
+          <p:cNvPr id="14" name=""/>
+          <p:cNvPicPr>
+            <a:picLocks xmlns:a="http://schemas.openxmlformats.org/drawingml/2006/main" noChangeAspect="1"/>
+          </p:cNvPicPr>
+          <p:nvPr/>
+        </p:nvPicPr>
+        <p:blipFill>
+          <a:blip xmlns:r="http://schemas.openxmlformats.org/officeDocument/2006/relationships" xmlns:a="http://schemas.openxmlformats.org/drawingml/2006/main" r:embed="R34d6b18e73e045e2"/>
+          <a:stretch xmlns:a="http://schemas.openxmlformats.org/drawingml/2006/main"/>
+        </p:blipFill>
+        <p:spPr>
+          <a:xfrm xmlns:a="http://schemas.openxmlformats.org/drawingml/2006/main">
+            <a:off x="11239500" y="6172200"/>
+            <a:ext cx="457200" cy="457200"/>
+          </a:xfrm>
+          <a:prstGeom xmlns:a="http://schemas.openxmlformats.org/drawingml/2006/main" prst="rect">
+            <a:avLst/>
+          </a:prstGeom>
+        </p:spPr>
+      </p:pic>
     </p:spTree>
     <p:extLst>
       <p:ext uri="{BB962C8B-B14F-4D97-AF65-F5344CB8AC3E}">
@@ -2350,11 +2306,11 @@
             <a:r>
               <a:rPr sz="3900" b="1">
                 <a:solidFill>
-                  <a:srgbClr val="111814"/>
-                </a:solidFill>
-                <a:latin typeface="Arial"/>
-                <a:ea typeface="Arial"/>
-                <a:cs typeface="Arial"/>
+                  <a:srgbClr val="3C4C1E"/>
+                </a:solidFill>
+                <a:latin typeface="League Spartan"/>
+                <a:ea typeface="League Spartan"/>
+                <a:cs typeface="League Spartan"/>
               </a:rPr>
               <a:t>Três ações substituem uma tela.</a:t>
             </a:r>
@@ -2384,7 +2340,7 @@
             <a:avLst/>
           </a:prstGeom>
           <a:solidFill xmlns:a="http://schemas.openxmlformats.org/drawingml/2006/main">
-            <a:srgbClr val="C4CCC7"/>
+            <a:srgbClr val="C9D1BC"/>
           </a:solidFill>
           <a:ln xmlns:a="http://schemas.openxmlformats.org/drawingml/2006/main" w="0">
             <a:noFill/>
@@ -2417,11 +2373,11 @@
             </a:avLst>
           </a:prstGeom>
           <a:solidFill xmlns:a="http://schemas.openxmlformats.org/drawingml/2006/main">
-            <a:srgbClr val="2F7D4A"/>
+            <a:srgbClr val="FCC931"/>
           </a:solidFill>
-          <a:ln xmlns:a="http://schemas.openxmlformats.org/drawingml/2006/main" w="9525">
+          <a:ln xmlns:a="http://schemas.openxmlformats.org/drawingml/2006/main" w="19050">
             <a:solidFill>
-              <a:srgbClr val="2F7D4A"/>
+              <a:srgbClr val="3C4C1E"/>
             </a:solidFill>
             <a:prstDash val="solid"/>
           </a:ln>
@@ -2475,11 +2431,11 @@
             <a:r>
               <a:rPr sz="1800" b="1">
                 <a:solidFill>
-                  <a:srgbClr val="174A2B"/>
-                </a:solidFill>
-                <a:latin typeface="Arial"/>
-                <a:ea typeface="Arial"/>
-                <a:cs typeface="Arial"/>
+                  <a:srgbClr val="3C4C1E"/>
+                </a:solidFill>
+                <a:latin typeface="League Spartan"/>
+                <a:ea typeface="League Spartan"/>
+                <a:cs typeface="League Spartan"/>
               </a:rPr>
               <a:t>01  OLHAR</a:t>
             </a:r>
@@ -2534,11 +2490,11 @@
             <a:r>
               <a:rPr sz="1950" b="0">
                 <a:solidFill>
-                  <a:srgbClr val="111814"/>
-                </a:solidFill>
-                <a:latin typeface="Arial"/>
-                <a:ea typeface="Arial"/>
-                <a:cs typeface="Arial"/>
+                  <a:srgbClr val="0F3C65"/>
+                </a:solidFill>
+                <a:latin typeface="League Spartan"/>
+                <a:ea typeface="League Spartan"/>
+                <a:cs typeface="League Spartan"/>
               </a:rPr>
               <a:t>Placa + QR resolvem o plot.
 O ID falado também é validado.</a:t>
@@ -2571,11 +2527,11 @@
             </a:avLst>
           </a:prstGeom>
           <a:solidFill xmlns:a="http://schemas.openxmlformats.org/drawingml/2006/main">
-            <a:srgbClr val="2F7D4A"/>
+            <a:srgbClr val="FCC931"/>
           </a:solidFill>
-          <a:ln xmlns:a="http://schemas.openxmlformats.org/drawingml/2006/main" w="9525">
+          <a:ln xmlns:a="http://schemas.openxmlformats.org/drawingml/2006/main" w="19050">
             <a:solidFill>
-              <a:srgbClr val="2F7D4A"/>
+              <a:srgbClr val="3C4C1E"/>
             </a:solidFill>
             <a:prstDash val="solid"/>
           </a:ln>
@@ -2629,11 +2585,11 @@
             <a:r>
               <a:rPr sz="1800" b="1">
                 <a:solidFill>
-                  <a:srgbClr val="174A2B"/>
-                </a:solidFill>
-                <a:latin typeface="Arial"/>
-                <a:ea typeface="Arial"/>
-                <a:cs typeface="Arial"/>
+                  <a:srgbClr val="3C4C1E"/>
+                </a:solidFill>
+                <a:latin typeface="League Spartan"/>
+                <a:ea typeface="League Spartan"/>
+                <a:cs typeface="League Spartan"/>
               </a:rPr>
               <a:t>02  FALAR</a:t>
             </a:r>
@@ -2688,11 +2644,11 @@
             <a:r>
               <a:rPr sz="1950" b="0">
                 <a:solidFill>
-                  <a:srgbClr val="111814"/>
-                </a:solidFill>
-                <a:latin typeface="Arial"/>
-                <a:ea typeface="Arial"/>
-                <a:cs typeface="Arial"/>
+                  <a:srgbClr val="0F3C65"/>
+                </a:solidFill>
+                <a:latin typeface="League Spartan"/>
+                <a:ea typeface="League Spartan"/>
+                <a:cs typeface="League Spartan"/>
               </a:rPr>
               <a:t>Softmax local
 65 KB · 4 intenções
@@ -2726,11 +2682,11 @@
             </a:avLst>
           </a:prstGeom>
           <a:solidFill xmlns:a="http://schemas.openxmlformats.org/drawingml/2006/main">
-            <a:srgbClr val="2F7D4A"/>
+            <a:srgbClr val="FCC931"/>
           </a:solidFill>
-          <a:ln xmlns:a="http://schemas.openxmlformats.org/drawingml/2006/main" w="9525">
+          <a:ln xmlns:a="http://schemas.openxmlformats.org/drawingml/2006/main" w="19050">
             <a:solidFill>
-              <a:srgbClr val="2F7D4A"/>
+              <a:srgbClr val="3C4C1E"/>
             </a:solidFill>
             <a:prstDash val="solid"/>
           </a:ln>
@@ -2784,11 +2740,11 @@
             <a:r>
               <a:rPr sz="1800" b="1">
                 <a:solidFill>
-                  <a:srgbClr val="174A2B"/>
-                </a:solidFill>
-                <a:latin typeface="Arial"/>
-                <a:ea typeface="Arial"/>
-                <a:cs typeface="Arial"/>
+                  <a:srgbClr val="3C4C1E"/>
+                </a:solidFill>
+                <a:latin typeface="League Spartan"/>
+                <a:ea typeface="League Spartan"/>
+                <a:cs typeface="League Spartan"/>
               </a:rPr>
               <a:t>03  CONFIRMAR</a:t>
             </a:r>
@@ -2843,11 +2799,11 @@
             <a:r>
               <a:rPr sz="1950" b="0">
                 <a:solidFill>
-                  <a:srgbClr val="111814"/>
-                </a:solidFill>
-                <a:latin typeface="Arial"/>
-                <a:ea typeface="Arial"/>
-                <a:cs typeface="Arial"/>
+                  <a:srgbClr val="0F3C65"/>
+                </a:solidFill>
+                <a:latin typeface="League Spartan"/>
+                <a:ea typeface="League Spartan"/>
+                <a:cs typeface="League Spartan"/>
               </a:rPr>
               <a:t>Só o ‘sim’ libera o comando ao robô.</a:t>
             </a:r>
@@ -2879,7 +2835,7 @@
             </a:avLst>
           </a:prstGeom>
           <a:solidFill xmlns:a="http://schemas.openxmlformats.org/drawingml/2006/main">
-            <a:srgbClr val="DDEEE2"/>
+            <a:srgbClr val="FFF4C7"/>
           </a:solidFill>
           <a:ln xmlns:a="http://schemas.openxmlformats.org/drawingml/2006/main" w="0">
             <a:noFill/>
@@ -2935,76 +2891,39 @@
             <a:r>
               <a:rPr sz="1875" b="1">
                 <a:solidFill>
-                  <a:srgbClr val="174A2B"/>
-                </a:solidFill>
-                <a:latin typeface="Arial"/>
-                <a:ea typeface="Arial"/>
-                <a:cs typeface="Arial"/>
+                  <a:srgbClr val="3C4C1E"/>
+                </a:solidFill>
+                <a:latin typeface="League Spartan"/>
+                <a:ea typeface="League Spartan"/>
+                <a:cs typeface="League Spartan"/>
               </a:rPr>
               <a:t>Voz ≠ câmera ou falta de confirmação = nenhum comando.</a:t>
             </a:r>
           </a:p>
         </p:txBody>
       </p:sp>
-      <p:sp>
-        <p:nvSpPr>
-          <p:cNvPr id="14" name="footer-3">
-            <a:extLst xmlns:a="http://schemas.openxmlformats.org/drawingml/2006/main">
-              <a:ext uri="{FF2B5EF4-FFF2-40B4-BE49-F238E27FC236}">
-                <a16:creationId xmlns:a16="http://schemas.microsoft.com/office/drawing/2014/main" id="{83A26C9B-915A-4C1F-BDAB-09E04BF9A22E}"/>
-              </a:ext>
-            </a:extLst>
-          </p:cNvPr>
-          <p:cNvSpPr>
-            <a:spLocks xmlns:a="http://schemas.openxmlformats.org/drawingml/2006/main" noGrp="1"/>
-          </p:cNvSpPr>
-          <p:nvPr/>
-        </p:nvSpPr>
-        <p:spPr>
-          <a:xfrm xmlns:a="http://schemas.openxmlformats.org/drawingml/2006/main">
-            <a:off x="11334750" y="6334125"/>
-            <a:ext cx="457200" cy="209550"/>
-          </a:xfrm>
-          <a:prstGeom xmlns:a="http://schemas.openxmlformats.org/drawingml/2006/main" prst="rect">
-            <a:avLst/>
-          </a:prstGeom>
-          <a:noFill xmlns:a="http://schemas.openxmlformats.org/drawingml/2006/main"/>
-          <a:ln xmlns:a="http://schemas.openxmlformats.org/drawingml/2006/main" w="0">
-            <a:noFill/>
-            <a:prstDash val="solid"/>
-          </a:ln>
-        </p:spPr>
-        <p:txBody>
-          <a:bodyPr xmlns:a="http://schemas.openxmlformats.org/drawingml/2006/main" anchor="b">
-            <a:noAutofit/>
-          </a:bodyPr>
-          <a:lstStyle xmlns:a="http://schemas.openxmlformats.org/drawingml/2006/main"/>
-          <a:p xmlns:a="http://schemas.openxmlformats.org/drawingml/2006/main">
-            <a:pPr algn="r">
-              <a:buNone/>
-              <a:defRPr sz="1200" b="0">
-                <a:solidFill>
-                  <a:srgbClr val="5E6B62"/>
-                </a:solidFill>
-                <a:latin typeface="Arial"/>
-                <a:ea typeface="Arial"/>
-                <a:cs typeface="Arial"/>
-              </a:defRPr>
-            </a:pPr>
-            <a:r>
-              <a:rPr sz="1200" b="0">
-                <a:solidFill>
-                  <a:srgbClr val="5E6B62"/>
-                </a:solidFill>
-                <a:latin typeface="Arial"/>
-                <a:ea typeface="Arial"/>
-                <a:cs typeface="Arial"/>
-              </a:rPr>
-              <a:t>03</a:t>
-            </a:r>
-          </a:p>
-        </p:txBody>
-      </p:sp>
+      <p:pic>
+        <p:nvPicPr>
+          <p:cNvPr id="30" name=""/>
+          <p:cNvPicPr>
+            <a:picLocks xmlns:a="http://schemas.openxmlformats.org/drawingml/2006/main" noChangeAspect="1"/>
+          </p:cNvPicPr>
+          <p:nvPr/>
+        </p:nvPicPr>
+        <p:blipFill>
+          <a:blip xmlns:r="http://schemas.openxmlformats.org/officeDocument/2006/relationships" xmlns:a="http://schemas.openxmlformats.org/drawingml/2006/main" r:embed="R3dbad23fc9c64ce7"/>
+          <a:stretch xmlns:a="http://schemas.openxmlformats.org/drawingml/2006/main"/>
+        </p:blipFill>
+        <p:spPr>
+          <a:xfrm xmlns:a="http://schemas.openxmlformats.org/drawingml/2006/main">
+            <a:off x="11239500" y="6172200"/>
+            <a:ext cx="457200" cy="457200"/>
+          </a:xfrm>
+          <a:prstGeom xmlns:a="http://schemas.openxmlformats.org/drawingml/2006/main" prst="rect">
+            <a:avLst/>
+          </a:prstGeom>
+        </p:spPr>
+      </p:pic>
     </p:spTree>
     <p:extLst>
       <p:ext uri="{BB962C8B-B14F-4D97-AF65-F5344CB8AC3E}">
@@ -3082,11 +3001,11 @@
             <a:r>
               <a:rPr sz="3900" b="1">
                 <a:solidFill>
-                  <a:srgbClr val="111814"/>
-                </a:solidFill>
-                <a:latin typeface="Arial"/>
-                <a:ea typeface="Arial"/>
-                <a:cs typeface="Arial"/>
+                  <a:srgbClr val="3C4C1E"/>
+                </a:solidFill>
+                <a:latin typeface="League Spartan"/>
+                <a:ea typeface="League Spartan"/>
+                <a:cs typeface="League Spartan"/>
               </a:rPr>
               <a:t>O ciclo completo já funciona em simulação.</a:t>
             </a:r>
@@ -3116,10 +3035,12 @@
             <a:avLst/>
           </a:prstGeom>
           <a:solidFill xmlns:a="http://schemas.openxmlformats.org/drawingml/2006/main">
-            <a:srgbClr val="2F7D4A"/>
+            <a:srgbClr val="FCC931"/>
           </a:solidFill>
-          <a:ln xmlns:a="http://schemas.openxmlformats.org/drawingml/2006/main" w="0">
-            <a:noFill/>
+          <a:ln xmlns:a="http://schemas.openxmlformats.org/drawingml/2006/main" w="9525">
+            <a:solidFill>
+              <a:srgbClr val="3C4C1E"/>
+            </a:solidFill>
             <a:prstDash val="solid"/>
           </a:ln>
         </p:spPr>
@@ -3147,10 +3068,12 @@
             <a:avLst/>
           </a:prstGeom>
           <a:solidFill xmlns:a="http://schemas.openxmlformats.org/drawingml/2006/main">
-            <a:srgbClr val="2F7D4A"/>
+            <a:srgbClr val="FCC931"/>
           </a:solidFill>
-          <a:ln xmlns:a="http://schemas.openxmlformats.org/drawingml/2006/main" w="0">
-            <a:noFill/>
+          <a:ln xmlns:a="http://schemas.openxmlformats.org/drawingml/2006/main" w="9525">
+            <a:solidFill>
+              <a:srgbClr val="3C4C1E"/>
+            </a:solidFill>
             <a:prstDash val="solid"/>
           </a:ln>
         </p:spPr>
@@ -3178,10 +3101,12 @@
             <a:avLst/>
           </a:prstGeom>
           <a:solidFill xmlns:a="http://schemas.openxmlformats.org/drawingml/2006/main">
-            <a:srgbClr val="2F7D4A"/>
+            <a:srgbClr val="FCC931"/>
           </a:solidFill>
-          <a:ln xmlns:a="http://schemas.openxmlformats.org/drawingml/2006/main" w="0">
-            <a:noFill/>
+          <a:ln xmlns:a="http://schemas.openxmlformats.org/drawingml/2006/main" w="9525">
+            <a:solidFill>
+              <a:srgbClr val="3C4C1E"/>
+            </a:solidFill>
             <a:prstDash val="solid"/>
           </a:ln>
         </p:spPr>
@@ -3211,11 +3136,11 @@
             </a:avLst>
           </a:prstGeom>
           <a:solidFill xmlns:a="http://schemas.openxmlformats.org/drawingml/2006/main">
-            <a:srgbClr val="EEF1EF"/>
+            <a:srgbClr val="FFFDF5"/>
           </a:solidFill>
           <a:ln xmlns:a="http://schemas.openxmlformats.org/drawingml/2006/main" w="9525">
             <a:solidFill>
-              <a:srgbClr val="C4CCC7"/>
+              <a:srgbClr val="C9D1BC"/>
             </a:solidFill>
             <a:prstDash val="solid"/>
           </a:ln>
@@ -3244,7 +3169,7 @@
             <a:avLst/>
           </a:prstGeom>
           <a:solidFill xmlns:a="http://schemas.openxmlformats.org/drawingml/2006/main">
-            <a:srgbClr val="2F7D4A"/>
+            <a:srgbClr val="FCC931"/>
           </a:solidFill>
           <a:ln xmlns:a="http://schemas.openxmlformats.org/drawingml/2006/main" w="0">
             <a:noFill/>
@@ -3300,11 +3225,11 @@
             <a:r>
               <a:rPr sz="2025" b="1">
                 <a:solidFill>
-                  <a:srgbClr val="111814"/>
-                </a:solidFill>
-                <a:latin typeface="Arial"/>
-                <a:ea typeface="Arial"/>
-                <a:cs typeface="Arial"/>
+                  <a:srgbClr val="3C4C1E"/>
+                </a:solidFill>
+                <a:latin typeface="League Spartan"/>
+                <a:ea typeface="League Spartan"/>
+                <a:cs typeface="League Spartan"/>
               </a:rPr>
               <a:t>AI Glasses</a:t>
             </a:r>
@@ -3359,11 +3284,11 @@
             <a:r>
               <a:rPr sz="1650" b="0">
                 <a:solidFill>
-                  <a:srgbClr val="5E6B62"/>
-                </a:solidFill>
-                <a:latin typeface="Arial"/>
-                <a:ea typeface="Arial"/>
-                <a:cs typeface="Arial"/>
+                  <a:srgbClr val="0F3C65"/>
+                </a:solidFill>
+                <a:latin typeface="League Spartan"/>
+                <a:ea typeface="League Spartan"/>
+                <a:cs typeface="League Spartan"/>
               </a:rPr>
               <a:t>câmera via DAT</a:t>
             </a:r>
@@ -3383,11 +3308,11 @@
             <a:r>
               <a:rPr sz="1650" b="0">
                 <a:solidFill>
-                  <a:srgbClr val="5E6B62"/>
-                </a:solidFill>
-                <a:latin typeface="Arial"/>
-                <a:ea typeface="Arial"/>
-                <a:cs typeface="Arial"/>
+                  <a:srgbClr val="0F3C65"/>
+                </a:solidFill>
+                <a:latin typeface="League Spartan"/>
+                <a:ea typeface="League Spartan"/>
+                <a:cs typeface="League Spartan"/>
               </a:rPr>
               <a:t>placa + QR</a:t>
             </a:r>
@@ -3407,11 +3332,11 @@
             <a:r>
               <a:rPr sz="1650" b="0">
                 <a:solidFill>
-                  <a:srgbClr val="5E6B62"/>
-                </a:solidFill>
-                <a:latin typeface="Arial"/>
-                <a:ea typeface="Arial"/>
-                <a:cs typeface="Arial"/>
+                  <a:srgbClr val="0F3C65"/>
+                </a:solidFill>
+                <a:latin typeface="League Spartan"/>
+                <a:ea typeface="League Spartan"/>
+                <a:cs typeface="League Spartan"/>
               </a:rPr>
               <a:t>voz/TTS nativos</a:t>
             </a:r>
@@ -3443,11 +3368,11 @@
             </a:avLst>
           </a:prstGeom>
           <a:solidFill xmlns:a="http://schemas.openxmlformats.org/drawingml/2006/main">
-            <a:srgbClr val="EEF1EF"/>
+            <a:srgbClr val="FFFDF5"/>
           </a:solidFill>
           <a:ln xmlns:a="http://schemas.openxmlformats.org/drawingml/2006/main" w="9525">
             <a:solidFill>
-              <a:srgbClr val="C4CCC7"/>
+              <a:srgbClr val="C9D1BC"/>
             </a:solidFill>
             <a:prstDash val="solid"/>
           </a:ln>
@@ -3476,7 +3401,7 @@
             <a:avLst/>
           </a:prstGeom>
           <a:solidFill xmlns:a="http://schemas.openxmlformats.org/drawingml/2006/main">
-            <a:srgbClr val="2F7D4A"/>
+            <a:srgbClr val="FCC931"/>
           </a:solidFill>
           <a:ln xmlns:a="http://schemas.openxmlformats.org/drawingml/2006/main" w="0">
             <a:noFill/>
@@ -3532,11 +3457,11 @@
             <a:r>
               <a:rPr sz="2025" b="1">
                 <a:solidFill>
-                  <a:srgbClr val="111814"/>
-                </a:solidFill>
-                <a:latin typeface="Arial"/>
-                <a:ea typeface="Arial"/>
-                <a:cs typeface="Arial"/>
+                  <a:srgbClr val="3C4C1E"/>
+                </a:solidFill>
+                <a:latin typeface="League Spartan"/>
+                <a:ea typeface="League Spartan"/>
+                <a:cs typeface="League Spartan"/>
               </a:rPr>
               <a:t>App nativo</a:t>
             </a:r>
@@ -3591,11 +3516,11 @@
             <a:r>
               <a:rPr sz="1650" b="0">
                 <a:solidFill>
-                  <a:srgbClr val="5E6B62"/>
-                </a:solidFill>
-                <a:latin typeface="Arial"/>
-                <a:ea typeface="Arial"/>
-                <a:cs typeface="Arial"/>
+                  <a:srgbClr val="0F3C65"/>
+                </a:solidFill>
+                <a:latin typeface="League Spartan"/>
+                <a:ea typeface="League Spartan"/>
+                <a:cs typeface="League Spartan"/>
               </a:rPr>
               <a:t>Kotlin / Swift</a:t>
             </a:r>
@@ -3615,11 +3540,11 @@
             <a:r>
               <a:rPr sz="1650" b="0">
                 <a:solidFill>
-                  <a:srgbClr val="5E6B62"/>
-                </a:solidFill>
-                <a:latin typeface="Arial"/>
-                <a:ea typeface="Arial"/>
-                <a:cs typeface="Arial"/>
+                  <a:srgbClr val="0F3C65"/>
+                </a:solidFill>
+                <a:latin typeface="League Spartan"/>
+                <a:ea typeface="League Spartan"/>
+                <a:cs typeface="League Spartan"/>
               </a:rPr>
               <a:t>softmax · 65 KB</a:t>
             </a:r>
@@ -3639,11 +3564,11 @@
             <a:r>
               <a:rPr sz="1650" b="0">
                 <a:solidFill>
-                  <a:srgbClr val="5E6B62"/>
-                </a:solidFill>
-                <a:latin typeface="Arial"/>
-                <a:ea typeface="Arial"/>
-                <a:cs typeface="Arial"/>
+                  <a:srgbClr val="0F3C65"/>
+                </a:solidFill>
+                <a:latin typeface="League Spartan"/>
+                <a:ea typeface="League Spartan"/>
+                <a:cs typeface="League Spartan"/>
               </a:rPr>
               <a:t>confirmação</a:t>
             </a:r>
@@ -3675,11 +3600,11 @@
             </a:avLst>
           </a:prstGeom>
           <a:solidFill xmlns:a="http://schemas.openxmlformats.org/drawingml/2006/main">
-            <a:srgbClr val="EEF1EF"/>
+            <a:srgbClr val="FFFDF5"/>
           </a:solidFill>
           <a:ln xmlns:a="http://schemas.openxmlformats.org/drawingml/2006/main" w="9525">
             <a:solidFill>
-              <a:srgbClr val="C4CCC7"/>
+              <a:srgbClr val="C9D1BC"/>
             </a:solidFill>
             <a:prstDash val="solid"/>
           </a:ln>
@@ -3708,7 +3633,7 @@
             <a:avLst/>
           </a:prstGeom>
           <a:solidFill xmlns:a="http://schemas.openxmlformats.org/drawingml/2006/main">
-            <a:srgbClr val="2F7D4A"/>
+            <a:srgbClr val="FCC931"/>
           </a:solidFill>
           <a:ln xmlns:a="http://schemas.openxmlformats.org/drawingml/2006/main" w="0">
             <a:noFill/>
@@ -3764,11 +3689,11 @@
             <a:r>
               <a:rPr sz="2025" b="1">
                 <a:solidFill>
-                  <a:srgbClr val="111814"/>
-                </a:solidFill>
-                <a:latin typeface="Arial"/>
-                <a:ea typeface="Arial"/>
-                <a:cs typeface="Arial"/>
+                  <a:srgbClr val="3C4C1E"/>
+                </a:solidFill>
+                <a:latin typeface="League Spartan"/>
+                <a:ea typeface="League Spartan"/>
+                <a:cs typeface="League Spartan"/>
               </a:rPr>
               <a:t>WebSocket</a:t>
             </a:r>
@@ -3823,11 +3748,11 @@
             <a:r>
               <a:rPr sz="1650" b="0">
                 <a:solidFill>
-                  <a:srgbClr val="5E6B62"/>
-                </a:solidFill>
-                <a:latin typeface="Arial"/>
-                <a:ea typeface="Arial"/>
-                <a:cs typeface="Arial"/>
+                  <a:srgbClr val="0F3C65"/>
+                </a:solidFill>
+                <a:latin typeface="League Spartan"/>
+                <a:ea typeface="League Spartan"/>
+                <a:cs typeface="League Spartan"/>
               </a:rPr>
               <a:t>JSON versionado</a:t>
             </a:r>
@@ -3847,11 +3772,11 @@
             <a:r>
               <a:rPr sz="1650" b="0">
                 <a:solidFill>
-                  <a:srgbClr val="5E6B62"/>
-                </a:solidFill>
-                <a:latin typeface="Arial"/>
-                <a:ea typeface="Arial"/>
-                <a:cs typeface="Arial"/>
+                  <a:srgbClr val="0F3C65"/>
+                </a:solidFill>
+                <a:latin typeface="League Spartan"/>
+                <a:ea typeface="League Spartan"/>
+                <a:cs typeface="League Spartan"/>
               </a:rPr>
               <a:t>expiração</a:t>
             </a:r>
@@ -3871,11 +3796,11 @@
             <a:r>
               <a:rPr sz="1650" b="0">
                 <a:solidFill>
-                  <a:srgbClr val="5E6B62"/>
-                </a:solidFill>
-                <a:latin typeface="Arial"/>
-                <a:ea typeface="Arial"/>
-                <a:cs typeface="Arial"/>
+                  <a:srgbClr val="0F3C65"/>
+                </a:solidFill>
+                <a:latin typeface="League Spartan"/>
+                <a:ea typeface="League Spartan"/>
+                <a:cs typeface="League Spartan"/>
               </a:rPr>
               <a:t>idempotência</a:t>
             </a:r>
@@ -3907,11 +3832,11 @@
             </a:avLst>
           </a:prstGeom>
           <a:solidFill xmlns:a="http://schemas.openxmlformats.org/drawingml/2006/main">
-            <a:srgbClr val="EEF1EF"/>
+            <a:srgbClr val="FFFDF5"/>
           </a:solidFill>
           <a:ln xmlns:a="http://schemas.openxmlformats.org/drawingml/2006/main" w="9525">
             <a:solidFill>
-              <a:srgbClr val="C4CCC7"/>
+              <a:srgbClr val="C9D1BC"/>
             </a:solidFill>
             <a:prstDash val="solid"/>
           </a:ln>
@@ -3940,7 +3865,7 @@
             <a:avLst/>
           </a:prstGeom>
           <a:solidFill xmlns:a="http://schemas.openxmlformats.org/drawingml/2006/main">
-            <a:srgbClr val="2F7D4A"/>
+            <a:srgbClr val="FCC931"/>
           </a:solidFill>
           <a:ln xmlns:a="http://schemas.openxmlformats.org/drawingml/2006/main" w="0">
             <a:noFill/>
@@ -3996,11 +3921,11 @@
             <a:r>
               <a:rPr sz="2025" b="1">
                 <a:solidFill>
-                  <a:srgbClr val="111814"/>
-                </a:solidFill>
-                <a:latin typeface="Arial"/>
-                <a:ea typeface="Arial"/>
-                <a:cs typeface="Arial"/>
+                  <a:srgbClr val="3C4C1E"/>
+                </a:solidFill>
+                <a:latin typeface="League Spartan"/>
+                <a:ea typeface="League Spartan"/>
+                <a:cs typeface="League Spartan"/>
               </a:rPr>
               <a:t>ROS 2 / Nav2</a:t>
             </a:r>
@@ -4055,11 +3980,11 @@
             <a:r>
               <a:rPr sz="1650" b="0">
                 <a:solidFill>
-                  <a:srgbClr val="5E6B62"/>
-                </a:solidFill>
-                <a:latin typeface="Arial"/>
-                <a:ea typeface="Arial"/>
-                <a:cs typeface="Arial"/>
+                  <a:srgbClr val="0F3C65"/>
+                </a:solidFill>
+                <a:latin typeface="League Spartan"/>
+                <a:ea typeface="League Spartan"/>
+                <a:cs typeface="League Spartan"/>
               </a:rPr>
               <a:t>bridge</a:t>
             </a:r>
@@ -4079,11 +4004,11 @@
             <a:r>
               <a:rPr sz="1650" b="0">
                 <a:solidFill>
-                  <a:srgbClr val="5E6B62"/>
-                </a:solidFill>
-                <a:latin typeface="Arial"/>
-                <a:ea typeface="Arial"/>
-                <a:cs typeface="Arial"/>
+                  <a:srgbClr val="0F3C65"/>
+                </a:solidFill>
+                <a:latin typeface="League Spartan"/>
+                <a:ea typeface="League Spartan"/>
+                <a:cs typeface="League Spartan"/>
               </a:rPr>
               <a:t>Gazebo</a:t>
             </a:r>
@@ -4103,11 +4028,11 @@
             <a:r>
               <a:rPr sz="1650" b="0">
                 <a:solidFill>
-                  <a:srgbClr val="5E6B62"/>
-                </a:solidFill>
-                <a:latin typeface="Arial"/>
-                <a:ea typeface="Arial"/>
-                <a:cs typeface="Arial"/>
+                  <a:srgbClr val="0F3C65"/>
+                </a:solidFill>
+                <a:latin typeface="League Spartan"/>
+                <a:ea typeface="League Spartan"/>
+                <a:cs typeface="League Spartan"/>
               </a:rPr>
               <a:t>TurtleBot 4</a:t>
             </a:r>
@@ -4139,7 +4064,7 @@
             </a:avLst>
           </a:prstGeom>
           <a:solidFill xmlns:a="http://schemas.openxmlformats.org/drawingml/2006/main">
-            <a:srgbClr val="DDEEE2"/>
+            <a:srgbClr val="FFF4C7"/>
           </a:solidFill>
           <a:ln xmlns:a="http://schemas.openxmlformats.org/drawingml/2006/main" w="0">
             <a:noFill/>
@@ -4195,76 +4120,39 @@
             <a:r>
               <a:rPr sz="1875" b="1">
                 <a:solidFill>
-                  <a:srgbClr val="174A2B"/>
-                </a:solidFill>
-                <a:latin typeface="Arial"/>
-                <a:ea typeface="Arial"/>
-                <a:cs typeface="Arial"/>
+                  <a:srgbClr val="3C4C1E"/>
+                </a:solidFill>
+                <a:latin typeface="League Spartan"/>
+                <a:ea typeface="League Spartan"/>
+                <a:cs typeface="League Spartan"/>
               </a:rPr>
               <a:t>Alvo visual + ID falado; se discordarem, nada é enviado. GPS não vira destino.</a:t>
             </a:r>
           </a:p>
         </p:txBody>
       </p:sp>
-      <p:sp>
-        <p:nvSpPr>
-          <p:cNvPr id="23" name="footer-4">
-            <a:extLst xmlns:a="http://schemas.openxmlformats.org/drawingml/2006/main">
-              <a:ext uri="{FF2B5EF4-FFF2-40B4-BE49-F238E27FC236}">
-                <a16:creationId xmlns:a16="http://schemas.microsoft.com/office/drawing/2014/main" id="{314403E2-B820-445B-B52C-8DFA455C7AF4}"/>
-              </a:ext>
-            </a:extLst>
-          </p:cNvPr>
-          <p:cNvSpPr>
-            <a:spLocks xmlns:a="http://schemas.openxmlformats.org/drawingml/2006/main" noGrp="1"/>
-          </p:cNvSpPr>
-          <p:nvPr/>
-        </p:nvSpPr>
-        <p:spPr>
-          <a:xfrm xmlns:a="http://schemas.openxmlformats.org/drawingml/2006/main">
-            <a:off x="11334750" y="6334125"/>
-            <a:ext cx="457200" cy="209550"/>
-          </a:xfrm>
-          <a:prstGeom xmlns:a="http://schemas.openxmlformats.org/drawingml/2006/main" prst="rect">
-            <a:avLst/>
-          </a:prstGeom>
-          <a:noFill xmlns:a="http://schemas.openxmlformats.org/drawingml/2006/main"/>
-          <a:ln xmlns:a="http://schemas.openxmlformats.org/drawingml/2006/main" w="0">
-            <a:noFill/>
-            <a:prstDash val="solid"/>
-          </a:ln>
-        </p:spPr>
-        <p:txBody>
-          <a:bodyPr xmlns:a="http://schemas.openxmlformats.org/drawingml/2006/main" anchor="b">
-            <a:noAutofit/>
-          </a:bodyPr>
-          <a:lstStyle xmlns:a="http://schemas.openxmlformats.org/drawingml/2006/main"/>
-          <a:p xmlns:a="http://schemas.openxmlformats.org/drawingml/2006/main">
-            <a:pPr algn="r">
-              <a:buNone/>
-              <a:defRPr sz="1200" b="0">
-                <a:solidFill>
-                  <a:srgbClr val="5E6B62"/>
-                </a:solidFill>
-                <a:latin typeface="Arial"/>
-                <a:ea typeface="Arial"/>
-                <a:cs typeface="Arial"/>
-              </a:defRPr>
-            </a:pPr>
-            <a:r>
-              <a:rPr sz="1200" b="0">
-                <a:solidFill>
-                  <a:srgbClr val="5E6B62"/>
-                </a:solidFill>
-                <a:latin typeface="Arial"/>
-                <a:ea typeface="Arial"/>
-                <a:cs typeface="Arial"/>
-              </a:rPr>
-              <a:t>04</a:t>
-            </a:r>
-          </a:p>
-        </p:txBody>
-      </p:sp>
+      <p:pic>
+        <p:nvPicPr>
+          <p:cNvPr id="48" name=""/>
+          <p:cNvPicPr>
+            <a:picLocks xmlns:a="http://schemas.openxmlformats.org/drawingml/2006/main" noChangeAspect="1"/>
+          </p:cNvPicPr>
+          <p:nvPr/>
+        </p:nvPicPr>
+        <p:blipFill>
+          <a:blip xmlns:r="http://schemas.openxmlformats.org/officeDocument/2006/relationships" xmlns:a="http://schemas.openxmlformats.org/drawingml/2006/main" r:embed="Rb5fc2efc513045bc"/>
+          <a:stretch xmlns:a="http://schemas.openxmlformats.org/drawingml/2006/main"/>
+        </p:blipFill>
+        <p:spPr>
+          <a:xfrm xmlns:a="http://schemas.openxmlformats.org/drawingml/2006/main">
+            <a:off x="11239500" y="6172200"/>
+            <a:ext cx="457200" cy="457200"/>
+          </a:xfrm>
+          <a:prstGeom xmlns:a="http://schemas.openxmlformats.org/drawingml/2006/main" prst="rect">
+            <a:avLst/>
+          </a:prstGeom>
+        </p:spPr>
+      </p:pic>
     </p:spTree>
     <p:extLst>
       <p:ext uri="{BB962C8B-B14F-4D97-AF65-F5344CB8AC3E}">
@@ -4342,11 +4230,11 @@
             <a:r>
               <a:rPr sz="3900" b="1">
                 <a:solidFill>
-                  <a:srgbClr val="111814"/>
-                </a:solidFill>
-                <a:latin typeface="Arial"/>
-                <a:ea typeface="Arial"/>
-                <a:cs typeface="Arial"/>
+                  <a:srgbClr val="3C4C1E"/>
+                </a:solidFill>
+                <a:latin typeface="League Spartan"/>
+                <a:ea typeface="League Spartan"/>
+                <a:cs typeface="League Spartan"/>
               </a:rPr>
               <a:t>A simulação já fecha o ciclo com falha segura.</a:t>
             </a:r>
@@ -4401,11 +4289,11 @@
             <a:r>
               <a:rPr sz="1950" b="0">
                 <a:solidFill>
-                  <a:srgbClr val="5E6B62"/>
-                </a:solidFill>
-                <a:latin typeface="Arial"/>
-                <a:ea typeface="Arial"/>
-                <a:cs typeface="Arial"/>
+                  <a:srgbClr val="0F3C65"/>
+                </a:solidFill>
+                <a:latin typeface="League Spartan"/>
+                <a:ea typeface="League Spartan"/>
+                <a:cs typeface="League Spartan"/>
               </a:rPr>
               <a:t>Três sinais reproduzíveis; o próximo gate é o hardware real.</a:t>
             </a:r>
@@ -4437,11 +4325,11 @@
             </a:avLst>
           </a:prstGeom>
           <a:solidFill xmlns:a="http://schemas.openxmlformats.org/drawingml/2006/main">
-            <a:srgbClr val="EEF1EF"/>
+            <a:srgbClr val="FFFDF5"/>
           </a:solidFill>
           <a:ln xmlns:a="http://schemas.openxmlformats.org/drawingml/2006/main" w="9525">
             <a:solidFill>
-              <a:srgbClr val="C4CCC7"/>
+              <a:srgbClr val="C9D1BC"/>
             </a:solidFill>
             <a:prstDash val="solid"/>
           </a:ln>
@@ -4495,11 +4383,11 @@
             <a:r>
               <a:rPr sz="5400" b="1">
                 <a:solidFill>
-                  <a:srgbClr val="174A2B"/>
-                </a:solidFill>
-                <a:latin typeface="Arial"/>
-                <a:ea typeface="Arial"/>
-                <a:cs typeface="Arial"/>
+                  <a:srgbClr val="3C4C1E"/>
+                </a:solidFill>
+                <a:latin typeface="League Spartan"/>
+                <a:ea typeface="League Spartan"/>
+                <a:cs typeface="League Spartan"/>
               </a:rPr>
               <a:t>QR</a:t>
             </a:r>
@@ -4554,11 +4442,11 @@
             <a:r>
               <a:rPr sz="1950" b="1">
                 <a:solidFill>
-                  <a:srgbClr val="111814"/>
-                </a:solidFill>
-                <a:latin typeface="Arial"/>
-                <a:ea typeface="Arial"/>
-                <a:cs typeface="Arial"/>
+                  <a:srgbClr val="0F3C65"/>
+                </a:solidFill>
+                <a:latin typeface="League Spartan"/>
+                <a:ea typeface="League Spartan"/>
+                <a:cs typeface="League Spartan"/>
               </a:rPr>
               <a:t>plot-03 detectado</a:t>
             </a:r>
@@ -4613,11 +4501,11 @@
             <a:r>
               <a:rPr sz="1575" b="0">
                 <a:solidFill>
-                  <a:srgbClr val="5E6B62"/>
-                </a:solidFill>
-                <a:latin typeface="Arial"/>
-                <a:ea typeface="Arial"/>
-                <a:cs typeface="Arial"/>
+                  <a:srgbClr val="0F3C65"/>
+                </a:solidFill>
+                <a:latin typeface="League Spartan"/>
+                <a:ea typeface="League Spartan"/>
+                <a:cs typeface="League Spartan"/>
               </a:rPr>
               <a:t>Placa completa decodificada localmente.</a:t>
             </a:r>
@@ -4649,11 +4537,11 @@
             </a:avLst>
           </a:prstGeom>
           <a:solidFill xmlns:a="http://schemas.openxmlformats.org/drawingml/2006/main">
-            <a:srgbClr val="EEF1EF"/>
+            <a:srgbClr val="FFFDF5"/>
           </a:solidFill>
           <a:ln xmlns:a="http://schemas.openxmlformats.org/drawingml/2006/main" w="9525">
             <a:solidFill>
-              <a:srgbClr val="C4CCC7"/>
+              <a:srgbClr val="C9D1BC"/>
             </a:solidFill>
             <a:prstDash val="solid"/>
           </a:ln>
@@ -4707,11 +4595,11 @@
             <a:r>
               <a:rPr sz="5400" b="1">
                 <a:solidFill>
-                  <a:srgbClr val="174A2B"/>
-                </a:solidFill>
-                <a:latin typeface="Arial"/>
-                <a:ea typeface="Arial"/>
-                <a:cs typeface="Arial"/>
+                  <a:srgbClr val="3C4C1E"/>
+                </a:solidFill>
+                <a:latin typeface="League Spartan"/>
+                <a:ea typeface="League Spartan"/>
+                <a:cs typeface="League Spartan"/>
               </a:rPr>
               <a:t>15/16</a:t>
             </a:r>
@@ -4766,11 +4654,11 @@
             <a:r>
               <a:rPr sz="1950" b="1">
                 <a:solidFill>
-                  <a:srgbClr val="111814"/>
-                </a:solidFill>
-                <a:latin typeface="Arial"/>
-                <a:ea typeface="Arial"/>
-                <a:cs typeface="Arial"/>
+                  <a:srgbClr val="0F3C65"/>
+                </a:solidFill>
+                <a:latin typeface="League Spartan"/>
+                <a:ea typeface="League Spartan"/>
+                <a:cs typeface="League Spartan"/>
               </a:rPr>
               <a:t>IA operacional</a:t>
             </a:r>
@@ -4825,11 +4713,11 @@
             <a:r>
               <a:rPr sz="1575" b="0">
                 <a:solidFill>
-                  <a:srgbClr val="5E6B62"/>
-                </a:solidFill>
-                <a:latin typeface="Arial"/>
-                <a:ea typeface="Arial"/>
-                <a:cs typeface="Arial"/>
+                  <a:srgbClr val="0F3C65"/>
+                </a:solidFill>
+                <a:latin typeface="League Spartan"/>
+                <a:ea typeface="League Spartan"/>
+                <a:cs typeface="League Spartan"/>
               </a:rPr>
               <a:t>96 frases; a restante virou UNKNOWN.</a:t>
             </a:r>
@@ -4861,11 +4749,11 @@
             </a:avLst>
           </a:prstGeom>
           <a:solidFill xmlns:a="http://schemas.openxmlformats.org/drawingml/2006/main">
-            <a:srgbClr val="EEF1EF"/>
+            <a:srgbClr val="FFFDF5"/>
           </a:solidFill>
           <a:ln xmlns:a="http://schemas.openxmlformats.org/drawingml/2006/main" w="9525">
             <a:solidFill>
-              <a:srgbClr val="C4CCC7"/>
+              <a:srgbClr val="C9D1BC"/>
             </a:solidFill>
             <a:prstDash val="solid"/>
           </a:ln>
@@ -4919,11 +4807,11 @@
             <a:r>
               <a:rPr sz="5400" b="1">
                 <a:solidFill>
-                  <a:srgbClr val="174A2B"/>
-                </a:solidFill>
-                <a:latin typeface="Arial"/>
-                <a:ea typeface="Arial"/>
-                <a:cs typeface="Arial"/>
+                  <a:srgbClr val="3C4C1E"/>
+                </a:solidFill>
+                <a:latin typeface="League Spartan"/>
+                <a:ea typeface="League Spartan"/>
+                <a:cs typeface="League Spartan"/>
               </a:rPr>
               <a:t>ROS 2</a:t>
             </a:r>
@@ -4978,11 +4866,11 @@
             <a:r>
               <a:rPr sz="1950" b="1">
                 <a:solidFill>
-                  <a:srgbClr val="111814"/>
-                </a:solidFill>
-                <a:latin typeface="Arial"/>
-                <a:ea typeface="Arial"/>
-                <a:cs typeface="Arial"/>
+                  <a:srgbClr val="0F3C65"/>
+                </a:solidFill>
+                <a:latin typeface="League Spartan"/>
+                <a:ea typeface="League Spartan"/>
+                <a:cs typeface="League Spartan"/>
               </a:rPr>
               <a:t>movimento provado</a:t>
             </a:r>
@@ -5037,11 +4925,11 @@
             <a:r>
               <a:rPr sz="1575" b="0">
                 <a:solidFill>
-                  <a:srgbClr val="5E6B62"/>
-                </a:solidFill>
-                <a:latin typeface="Arial"/>
-                <a:ea typeface="Arial"/>
-                <a:cs typeface="Arial"/>
+                  <a:srgbClr val="0F3C65"/>
+                </a:solidFill>
+                <a:latin typeface="League Spartan"/>
+                <a:ea typeface="League Spartan"/>
+                <a:cs typeface="League Spartan"/>
               </a:rPr>
               <a:t>ACCEPTED + Nav2 ativo + odometria mudou.</a:t>
             </a:r>
@@ -5096,76 +4984,39 @@
             <a:r>
               <a:rPr sz="2025" b="1">
                 <a:solidFill>
-                  <a:srgbClr val="174A2B"/>
-                </a:solidFill>
-                <a:latin typeface="Arial"/>
-                <a:ea typeface="Arial"/>
-                <a:cs typeface="Arial"/>
+                  <a:srgbClr val="3C4C1E"/>
+                </a:solidFill>
+                <a:latin typeface="League Spartan"/>
+                <a:ea typeface="League Spartan"/>
+                <a:cs typeface="League Spartan"/>
               </a:rPr>
               <a:t>Voz ≠ câmera, ‘cancelar’ ou falta de confirmação = sem comando.</a:t>
             </a:r>
           </a:p>
         </p:txBody>
       </p:sp>
-      <p:sp>
-        <p:nvSpPr>
-          <p:cNvPr id="16" name="footer-5">
-            <a:extLst xmlns:a="http://schemas.openxmlformats.org/drawingml/2006/main">
-              <a:ext uri="{FF2B5EF4-FFF2-40B4-BE49-F238E27FC236}">
-                <a16:creationId xmlns:a16="http://schemas.microsoft.com/office/drawing/2014/main" id="{F65433F2-F91B-463A-B1DF-EFAC302413C4}"/>
-              </a:ext>
-            </a:extLst>
-          </p:cNvPr>
-          <p:cNvSpPr>
-            <a:spLocks xmlns:a="http://schemas.openxmlformats.org/drawingml/2006/main" noGrp="1"/>
-          </p:cNvSpPr>
-          <p:nvPr/>
-        </p:nvSpPr>
-        <p:spPr>
-          <a:xfrm xmlns:a="http://schemas.openxmlformats.org/drawingml/2006/main">
-            <a:off x="11334750" y="6334125"/>
-            <a:ext cx="457200" cy="209550"/>
-          </a:xfrm>
-          <a:prstGeom xmlns:a="http://schemas.openxmlformats.org/drawingml/2006/main" prst="rect">
-            <a:avLst/>
-          </a:prstGeom>
-          <a:noFill xmlns:a="http://schemas.openxmlformats.org/drawingml/2006/main"/>
-          <a:ln xmlns:a="http://schemas.openxmlformats.org/drawingml/2006/main" w="0">
-            <a:noFill/>
-            <a:prstDash val="solid"/>
-          </a:ln>
-        </p:spPr>
-        <p:txBody>
-          <a:bodyPr xmlns:a="http://schemas.openxmlformats.org/drawingml/2006/main" anchor="b">
-            <a:noAutofit/>
-          </a:bodyPr>
-          <a:lstStyle xmlns:a="http://schemas.openxmlformats.org/drawingml/2006/main"/>
-          <a:p xmlns:a="http://schemas.openxmlformats.org/drawingml/2006/main">
-            <a:pPr algn="r">
-              <a:buNone/>
-              <a:defRPr sz="1200" b="0">
-                <a:solidFill>
-                  <a:srgbClr val="5E6B62"/>
-                </a:solidFill>
-                <a:latin typeface="Arial"/>
-                <a:ea typeface="Arial"/>
-                <a:cs typeface="Arial"/>
-              </a:defRPr>
-            </a:pPr>
-            <a:r>
-              <a:rPr sz="1200" b="0">
-                <a:solidFill>
-                  <a:srgbClr val="5E6B62"/>
-                </a:solidFill>
-                <a:latin typeface="Arial"/>
-                <a:ea typeface="Arial"/>
-                <a:cs typeface="Arial"/>
-              </a:rPr>
-              <a:t>05</a:t>
-            </a:r>
-          </a:p>
-        </p:txBody>
-      </p:sp>
+      <p:pic>
+        <p:nvPicPr>
+          <p:cNvPr id="34" name=""/>
+          <p:cNvPicPr>
+            <a:picLocks xmlns:a="http://schemas.openxmlformats.org/drawingml/2006/main" noChangeAspect="1"/>
+          </p:cNvPicPr>
+          <p:nvPr/>
+        </p:nvPicPr>
+        <p:blipFill>
+          <a:blip xmlns:r="http://schemas.openxmlformats.org/officeDocument/2006/relationships" xmlns:a="http://schemas.openxmlformats.org/drawingml/2006/main" r:embed="R5b75d32873374afb"/>
+          <a:stretch xmlns:a="http://schemas.openxmlformats.org/drawingml/2006/main"/>
+        </p:blipFill>
+        <p:spPr>
+          <a:xfrm xmlns:a="http://schemas.openxmlformats.org/drawingml/2006/main">
+            <a:off x="11239500" y="6172200"/>
+            <a:ext cx="457200" cy="457200"/>
+          </a:xfrm>
+          <a:prstGeom xmlns:a="http://schemas.openxmlformats.org/drawingml/2006/main" prst="rect">
+            <a:avLst/>
+          </a:prstGeom>
+        </p:spPr>
+      </p:pic>
     </p:spTree>
     <p:extLst>
       <p:ext uri="{BB962C8B-B14F-4D97-AF65-F5344CB8AC3E}">
@@ -5197,22 +5048,22 @@
       </p:grpSpPr>
       <p:sp>
         <p:nvSpPr>
-          <p:cNvPr id="5" name="close-overline">
-            <a:extLst xmlns:a="http://schemas.openxmlformats.org/drawingml/2006/main">
-              <a:ext uri="{FF2B5EF4-FFF2-40B4-BE49-F238E27FC236}">
-                <a16:creationId xmlns:a16="http://schemas.microsoft.com/office/drawing/2014/main" id="{B857CE6C-4BA9-4247-8B93-424B714C6728}"/>
-              </a:ext>
-            </a:extLst>
-          </p:cNvPr>
-          <p:cNvSpPr>
-            <a:spLocks xmlns:a="http://schemas.openxmlformats.org/drawingml/2006/main" noGrp="1"/>
-          </p:cNvSpPr>
-          <p:nvPr/>
-        </p:nvSpPr>
-        <p:spPr>
-          <a:xfrm xmlns:a="http://schemas.openxmlformats.org/drawingml/2006/main">
-            <a:off x="457200" y="457200"/>
-            <a:ext cx="3429000" cy="342900"/>
+          <p:cNvPr id="2" name="close-thesis">
+            <a:extLst xmlns:a="http://schemas.openxmlformats.org/drawingml/2006/main">
+              <a:ext uri="{FF2B5EF4-FFF2-40B4-BE49-F238E27FC236}">
+                <a16:creationId xmlns:a16="http://schemas.microsoft.com/office/drawing/2014/main" id="{28E06A39-AA9A-4146-BBA9-C188263EB56B}"/>
+              </a:ext>
+            </a:extLst>
+          </p:cNvPr>
+          <p:cNvSpPr>
+            <a:spLocks xmlns:a="http://schemas.openxmlformats.org/drawingml/2006/main" noGrp="1"/>
+          </p:cNvSpPr>
+          <p:nvPr/>
+        </p:nvSpPr>
+        <p:spPr>
+          <a:xfrm xmlns:a="http://schemas.openxmlformats.org/drawingml/2006/main">
+            <a:off x="457200" y="1714500"/>
+            <a:ext cx="10287000" cy="2286000"/>
           </a:xfrm>
           <a:prstGeom xmlns:a="http://schemas.openxmlformats.org/drawingml/2006/main" prst="rect">
             <a:avLst/>
@@ -5224,16 +5075,16 @@
           </a:ln>
         </p:spPr>
         <p:txBody>
-          <a:bodyPr xmlns:a="http://schemas.openxmlformats.org/drawingml/2006/main" anchor="t">
+          <a:bodyPr xmlns:a="http://schemas.openxmlformats.org/drawingml/2006/main" anchor="b">
             <a:noAutofit/>
           </a:bodyPr>
           <a:lstStyle xmlns:a="http://schemas.openxmlformats.org/drawingml/2006/main"/>
           <a:p xmlns:a="http://schemas.openxmlformats.org/drawingml/2006/main">
             <a:pPr algn="l">
               <a:buNone/>
-              <a:defRPr sz="1650" b="1">
-                <a:solidFill>
-                  <a:srgbClr val="2F7D4A"/>
+              <a:defRPr sz="5250" b="1">
+                <a:solidFill>
+                  <a:srgbClr val="111814"/>
                 </a:solidFill>
                 <a:latin typeface="Arial"/>
                 <a:ea typeface="Arial"/>
@@ -5241,37 +5092,37 @@
               </a:defRPr>
             </a:pPr>
             <a:r>
-              <a:rPr sz="1650" b="1">
-                <a:solidFill>
-                  <a:srgbClr val="2F7D4A"/>
-                </a:solidFill>
-                <a:latin typeface="Arial"/>
-                <a:ea typeface="Arial"/>
-                <a:cs typeface="Arial"/>
+              <a:rPr sz="5250" b="1">
+                <a:solidFill>
+                  <a:srgbClr val="3C4C1E"/>
+                </a:solidFill>
+                <a:latin typeface="League Spartan"/>
+                <a:ea typeface="League Spartan"/>
+                <a:cs typeface="League Spartan"/>
               </a:rPr>
-              <a:t>MAESTRO AGRÍCOLA</a:t>
-            </a:r>
-          </a:p>
-        </p:txBody>
-      </p:sp>
-      <p:sp>
-        <p:nvSpPr>
-          <p:cNvPr id="2" name="close-thesis">
-            <a:extLst xmlns:a="http://schemas.openxmlformats.org/drawingml/2006/main">
-              <a:ext uri="{FF2B5EF4-FFF2-40B4-BE49-F238E27FC236}">
-                <a16:creationId xmlns:a16="http://schemas.microsoft.com/office/drawing/2014/main" id="{28E06A39-AA9A-4146-BBA9-C188263EB56B}"/>
-              </a:ext>
-            </a:extLst>
-          </p:cNvPr>
-          <p:cNvSpPr>
-            <a:spLocks xmlns:a="http://schemas.openxmlformats.org/drawingml/2006/main" noGrp="1"/>
-          </p:cNvSpPr>
-          <p:nvPr/>
-        </p:nvSpPr>
-        <p:spPr>
-          <a:xfrm xmlns:a="http://schemas.openxmlformats.org/drawingml/2006/main">
-            <a:off x="457200" y="1714500"/>
-            <a:ext cx="10287000" cy="2286000"/>
+              <a:t>O futuro do campo não precisa de mais telas.</a:t>
+            </a:r>
+          </a:p>
+        </p:txBody>
+      </p:sp>
+      <p:sp>
+        <p:nvSpPr>
+          <p:cNvPr id="3" name="close-tagline">
+            <a:extLst xmlns:a="http://schemas.openxmlformats.org/drawingml/2006/main">
+              <a:ext uri="{FF2B5EF4-FFF2-40B4-BE49-F238E27FC236}">
+                <a16:creationId xmlns:a16="http://schemas.microsoft.com/office/drawing/2014/main" id="{0753BFD4-8DB1-4577-BAA0-53EE2B0BAAE9}"/>
+              </a:ext>
+            </a:extLst>
+          </p:cNvPr>
+          <p:cNvSpPr>
+            <a:spLocks xmlns:a="http://schemas.openxmlformats.org/drawingml/2006/main" noGrp="1"/>
+          </p:cNvSpPr>
+          <p:nvPr/>
+        </p:nvSpPr>
+        <p:spPr>
+          <a:xfrm xmlns:a="http://schemas.openxmlformats.org/drawingml/2006/main">
+            <a:off x="457200" y="4810125"/>
+            <a:ext cx="6858000" cy="762000"/>
           </a:xfrm>
           <a:prstGeom xmlns:a="http://schemas.openxmlformats.org/drawingml/2006/main" prst="rect">
             <a:avLst/>
@@ -5283,16 +5134,16 @@
           </a:ln>
         </p:spPr>
         <p:txBody>
-          <a:bodyPr xmlns:a="http://schemas.openxmlformats.org/drawingml/2006/main" anchor="b">
+          <a:bodyPr xmlns:a="http://schemas.openxmlformats.org/drawingml/2006/main" anchor="t">
             <a:noAutofit/>
           </a:bodyPr>
           <a:lstStyle xmlns:a="http://schemas.openxmlformats.org/drawingml/2006/main"/>
           <a:p xmlns:a="http://schemas.openxmlformats.org/drawingml/2006/main">
             <a:pPr algn="l">
               <a:buNone/>
-              <a:defRPr sz="5250" b="1">
-                <a:solidFill>
-                  <a:srgbClr val="111814"/>
+              <a:defRPr sz="3300" b="1">
+                <a:solidFill>
+                  <a:srgbClr val="174A2B"/>
                 </a:solidFill>
                 <a:latin typeface="Arial"/>
                 <a:ea typeface="Arial"/>
@@ -5300,72 +5151,13 @@
               </a:defRPr>
             </a:pPr>
             <a:r>
-              <a:rPr sz="5250" b="1">
-                <a:solidFill>
-                  <a:srgbClr val="111814"/>
-                </a:solidFill>
-                <a:latin typeface="Arial"/>
-                <a:ea typeface="Arial"/>
-                <a:cs typeface="Arial"/>
-              </a:rPr>
-              <a:t>O futuro do campo não precisa de mais telas.</a:t>
-            </a:r>
-          </a:p>
-        </p:txBody>
-      </p:sp>
-      <p:sp>
-        <p:nvSpPr>
-          <p:cNvPr id="3" name="close-tagline">
-            <a:extLst xmlns:a="http://schemas.openxmlformats.org/drawingml/2006/main">
-              <a:ext uri="{FF2B5EF4-FFF2-40B4-BE49-F238E27FC236}">
-                <a16:creationId xmlns:a16="http://schemas.microsoft.com/office/drawing/2014/main" id="{0753BFD4-8DB1-4577-BAA0-53EE2B0BAAE9}"/>
-              </a:ext>
-            </a:extLst>
-          </p:cNvPr>
-          <p:cNvSpPr>
-            <a:spLocks xmlns:a="http://schemas.openxmlformats.org/drawingml/2006/main" noGrp="1"/>
-          </p:cNvSpPr>
-          <p:nvPr/>
-        </p:nvSpPr>
-        <p:spPr>
-          <a:xfrm xmlns:a="http://schemas.openxmlformats.org/drawingml/2006/main">
-            <a:off x="457200" y="4810125"/>
-            <a:ext cx="6858000" cy="762000"/>
-          </a:xfrm>
-          <a:prstGeom xmlns:a="http://schemas.openxmlformats.org/drawingml/2006/main" prst="rect">
-            <a:avLst/>
-          </a:prstGeom>
-          <a:noFill xmlns:a="http://schemas.openxmlformats.org/drawingml/2006/main"/>
-          <a:ln xmlns:a="http://schemas.openxmlformats.org/drawingml/2006/main" w="0">
-            <a:noFill/>
-            <a:prstDash val="solid"/>
-          </a:ln>
-        </p:spPr>
-        <p:txBody>
-          <a:bodyPr xmlns:a="http://schemas.openxmlformats.org/drawingml/2006/main" anchor="t">
-            <a:noAutofit/>
-          </a:bodyPr>
-          <a:lstStyle xmlns:a="http://schemas.openxmlformats.org/drawingml/2006/main"/>
-          <a:p xmlns:a="http://schemas.openxmlformats.org/drawingml/2006/main">
-            <a:pPr algn="l">
-              <a:buNone/>
-              <a:defRPr sz="3300" b="1">
-                <a:solidFill>
-                  <a:srgbClr val="174A2B"/>
-                </a:solidFill>
-                <a:latin typeface="Arial"/>
-                <a:ea typeface="Arial"/>
-                <a:cs typeface="Arial"/>
-              </a:defRPr>
-            </a:pPr>
-            <a:r>
               <a:rPr sz="3300" b="1">
                 <a:solidFill>
-                  <a:srgbClr val="174A2B"/>
-                </a:solidFill>
-                <a:latin typeface="Arial"/>
-                <a:ea typeface="Arial"/>
-                <a:cs typeface="Arial"/>
+                  <a:srgbClr val="0F3C65"/>
+                </a:solidFill>
+                <a:latin typeface="League Spartan"/>
+                <a:ea typeface="League Spartan"/>
+                <a:cs typeface="League Spartan"/>
               </a:rPr>
               <a:t>Olhe. Fale. Confirme.</a:t>
             </a:r>
@@ -5395,7 +5187,7 @@
             <a:avLst/>
           </a:prstGeom>
           <a:solidFill xmlns:a="http://schemas.openxmlformats.org/drawingml/2006/main">
-            <a:srgbClr val="2F7D4A"/>
+            <a:srgbClr val="FCC931"/>
           </a:solidFill>
           <a:ln xmlns:a="http://schemas.openxmlformats.org/drawingml/2006/main" w="0">
             <a:noFill/>
@@ -5403,6 +5195,28 @@
           </a:ln>
         </p:spPr>
       </p:sp>
+      <p:pic>
+        <p:nvPicPr>
+          <p:cNvPr id="9" name=""/>
+          <p:cNvPicPr>
+            <a:picLocks xmlns:a="http://schemas.openxmlformats.org/drawingml/2006/main" noChangeAspect="1"/>
+          </p:cNvPicPr>
+          <p:nvPr/>
+        </p:nvPicPr>
+        <p:blipFill>
+          <a:blip xmlns:r="http://schemas.openxmlformats.org/officeDocument/2006/relationships" xmlns:a="http://schemas.openxmlformats.org/drawingml/2006/main" r:embed="R1073158c185d4ebb"/>
+          <a:stretch xmlns:a="http://schemas.openxmlformats.org/drawingml/2006/main"/>
+        </p:blipFill>
+        <p:spPr>
+          <a:xfrm xmlns:a="http://schemas.openxmlformats.org/drawingml/2006/main">
+            <a:off x="457200" y="363118"/>
+            <a:ext cx="4000500" cy="1169239"/>
+          </a:xfrm>
+          <a:prstGeom xmlns:a="http://schemas.openxmlformats.org/drawingml/2006/main" prst="rect">
+            <a:avLst/>
+          </a:prstGeom>
+        </p:spPr>
+      </p:pic>
     </p:spTree>
     <p:extLst>
       <p:ext uri="{BB962C8B-B14F-4D97-AF65-F5344CB8AC3E}">

</xml_diff>

<commit_message>
docs(pitch): apply visual identity v2
</commit_message>
<xml_diff>
--- a/docs/pitch/Maestro-Agricola-Pitch.pptx
+++ b/docs/pitch/Maestro-Agricola-Pitch.pptx
@@ -472,7 +472,7 @@
           </a:p>
           <a:p xmlns:a="http://schemas.openxmlformats.org/drawingml/2006/main">
             <a:r>
-              <a:t>- Identidade visual e logos: assets/brand, equipe AgroTurtles, 18 ago. 2026.</a:t>
+              <a:t>- Identidade visual e logos: assets/brand, equipe AgroTurtles, 19 ago. 2026.</a:t>
             </a:r>
           </a:p>
         </p:txBody>
@@ -957,7 +957,7 @@
           </a:p>
           <a:p xmlns:a="http://schemas.openxmlformats.org/drawingml/2006/main">
             <a:r>
-              <a:t>- Identidade visual e logos: assets/brand, equipe AgroTurtles, 18 ago. 2026.</a:t>
+              <a:t>- Identidade visual e logos: assets/brand, equipe AgroTurtles, 19 ago. 2026.</a:t>
             </a:r>
           </a:p>
         </p:txBody>
@@ -1571,6 +1571,29 @@
       <p:grpSpPr>
         <a:xfrm xmlns:a="http://schemas.openxmlformats.org/drawingml/2006/main"/>
       </p:grpSpPr>
+      <p:pic>
+        <p:nvPicPr>
+          <p:cNvPr id="17" name=""/>
+          <p:cNvPicPr>
+            <a:picLocks xmlns:a="http://schemas.openxmlformats.org/drawingml/2006/main" noChangeAspect="1"/>
+          </p:cNvPicPr>
+          <p:nvPr/>
+        </p:nvPicPr>
+        <p:blipFill>
+          <a:blip xmlns:r="http://schemas.openxmlformats.org/officeDocument/2006/relationships" xmlns:a="http://schemas.openxmlformats.org/drawingml/2006/main" r:embed="R73bd1ff95f2f4043"/>
+          <a:srcRect xmlns:a="http://schemas.openxmlformats.org/drawingml/2006/main" l="8000" t="30000" r="8500" b="33000"/>
+          <a:stretch xmlns:a="http://schemas.openxmlformats.org/drawingml/2006/main"/>
+        </p:blipFill>
+        <p:spPr>
+          <a:xfrm xmlns:a="http://schemas.openxmlformats.org/drawingml/2006/main">
+            <a:off x="462958" y="4857750"/>
+            <a:ext cx="4941484" cy="1143862"/>
+          </a:xfrm>
+          <a:prstGeom xmlns:a="http://schemas.openxmlformats.org/drawingml/2006/main" prst="rect">
+            <a:avLst/>
+          </a:prstGeom>
+        </p:spPr>
+      </p:pic>
       <p:sp>
         <p:nvSpPr>
           <p:cNvPr id="8" name="cover-accent">
@@ -1865,28 +1888,6 @@
           </a:p>
         </p:txBody>
       </p:sp>
-      <p:pic>
-        <p:nvPicPr>
-          <p:cNvPr id="17" name=""/>
-          <p:cNvPicPr>
-            <a:picLocks xmlns:a="http://schemas.openxmlformats.org/drawingml/2006/main" noChangeAspect="1"/>
-          </p:cNvPicPr>
-          <p:nvPr/>
-        </p:nvPicPr>
-        <p:blipFill>
-          <a:blip xmlns:r="http://schemas.openxmlformats.org/officeDocument/2006/relationships" xmlns:a="http://schemas.openxmlformats.org/drawingml/2006/main" r:embed="R73bd1ff95f2f4043"/>
-          <a:stretch xmlns:a="http://schemas.openxmlformats.org/drawingml/2006/main"/>
-        </p:blipFill>
-        <p:spPr>
-          <a:xfrm xmlns:a="http://schemas.openxmlformats.org/drawingml/2006/main">
-            <a:off x="462958" y="4857750"/>
-            <a:ext cx="4941484" cy="1381125"/>
-          </a:xfrm>
-          <a:prstGeom xmlns:a="http://schemas.openxmlformats.org/drawingml/2006/main" prst="rect">
-            <a:avLst/>
-          </a:prstGeom>
-        </p:spPr>
-      </p:pic>
     </p:spTree>
     <p:extLst>
       <p:ext uri="{BB962C8B-B14F-4D97-AF65-F5344CB8AC3E}">
@@ -4257,7 +4258,7 @@
         </p:nvSpPr>
         <p:spPr>
           <a:xfrm xmlns:a="http://schemas.openxmlformats.org/drawingml/2006/main">
-            <a:off x="457200" y="1181100"/>
+            <a:off x="457200" y="1650000"/>
             <a:ext cx="10668000" cy="514350"/>
           </a:xfrm>
           <a:prstGeom xmlns:a="http://schemas.openxmlformats.org/drawingml/2006/main" prst="rect">
@@ -5046,155 +5047,6 @@
       <p:grpSpPr>
         <a:xfrm xmlns:a="http://schemas.openxmlformats.org/drawingml/2006/main"/>
       </p:grpSpPr>
-      <p:sp>
-        <p:nvSpPr>
-          <p:cNvPr id="2" name="close-thesis">
-            <a:extLst xmlns:a="http://schemas.openxmlformats.org/drawingml/2006/main">
-              <a:ext uri="{FF2B5EF4-FFF2-40B4-BE49-F238E27FC236}">
-                <a16:creationId xmlns:a16="http://schemas.microsoft.com/office/drawing/2014/main" id="{28E06A39-AA9A-4146-BBA9-C188263EB56B}"/>
-              </a:ext>
-            </a:extLst>
-          </p:cNvPr>
-          <p:cNvSpPr>
-            <a:spLocks xmlns:a="http://schemas.openxmlformats.org/drawingml/2006/main" noGrp="1"/>
-          </p:cNvSpPr>
-          <p:nvPr/>
-        </p:nvSpPr>
-        <p:spPr>
-          <a:xfrm xmlns:a="http://schemas.openxmlformats.org/drawingml/2006/main">
-            <a:off x="457200" y="1714500"/>
-            <a:ext cx="10287000" cy="2286000"/>
-          </a:xfrm>
-          <a:prstGeom xmlns:a="http://schemas.openxmlformats.org/drawingml/2006/main" prst="rect">
-            <a:avLst/>
-          </a:prstGeom>
-          <a:noFill xmlns:a="http://schemas.openxmlformats.org/drawingml/2006/main"/>
-          <a:ln xmlns:a="http://schemas.openxmlformats.org/drawingml/2006/main" w="0">
-            <a:noFill/>
-            <a:prstDash val="solid"/>
-          </a:ln>
-        </p:spPr>
-        <p:txBody>
-          <a:bodyPr xmlns:a="http://schemas.openxmlformats.org/drawingml/2006/main" anchor="b">
-            <a:noAutofit/>
-          </a:bodyPr>
-          <a:lstStyle xmlns:a="http://schemas.openxmlformats.org/drawingml/2006/main"/>
-          <a:p xmlns:a="http://schemas.openxmlformats.org/drawingml/2006/main">
-            <a:pPr algn="l">
-              <a:buNone/>
-              <a:defRPr sz="5250" b="1">
-                <a:solidFill>
-                  <a:srgbClr val="111814"/>
-                </a:solidFill>
-                <a:latin typeface="Arial"/>
-                <a:ea typeface="Arial"/>
-                <a:cs typeface="Arial"/>
-              </a:defRPr>
-            </a:pPr>
-            <a:r>
-              <a:rPr sz="5250" b="1">
-                <a:solidFill>
-                  <a:srgbClr val="3C4C1E"/>
-                </a:solidFill>
-                <a:latin typeface="League Spartan"/>
-                <a:ea typeface="League Spartan"/>
-                <a:cs typeface="League Spartan"/>
-              </a:rPr>
-              <a:t>O futuro do campo não precisa de mais telas.</a:t>
-            </a:r>
-          </a:p>
-        </p:txBody>
-      </p:sp>
-      <p:sp>
-        <p:nvSpPr>
-          <p:cNvPr id="3" name="close-tagline">
-            <a:extLst xmlns:a="http://schemas.openxmlformats.org/drawingml/2006/main">
-              <a:ext uri="{FF2B5EF4-FFF2-40B4-BE49-F238E27FC236}">
-                <a16:creationId xmlns:a16="http://schemas.microsoft.com/office/drawing/2014/main" id="{0753BFD4-8DB1-4577-BAA0-53EE2B0BAAE9}"/>
-              </a:ext>
-            </a:extLst>
-          </p:cNvPr>
-          <p:cNvSpPr>
-            <a:spLocks xmlns:a="http://schemas.openxmlformats.org/drawingml/2006/main" noGrp="1"/>
-          </p:cNvSpPr>
-          <p:nvPr/>
-        </p:nvSpPr>
-        <p:spPr>
-          <a:xfrm xmlns:a="http://schemas.openxmlformats.org/drawingml/2006/main">
-            <a:off x="457200" y="4810125"/>
-            <a:ext cx="6858000" cy="762000"/>
-          </a:xfrm>
-          <a:prstGeom xmlns:a="http://schemas.openxmlformats.org/drawingml/2006/main" prst="rect">
-            <a:avLst/>
-          </a:prstGeom>
-          <a:noFill xmlns:a="http://schemas.openxmlformats.org/drawingml/2006/main"/>
-          <a:ln xmlns:a="http://schemas.openxmlformats.org/drawingml/2006/main" w="0">
-            <a:noFill/>
-            <a:prstDash val="solid"/>
-          </a:ln>
-        </p:spPr>
-        <p:txBody>
-          <a:bodyPr xmlns:a="http://schemas.openxmlformats.org/drawingml/2006/main" anchor="t">
-            <a:noAutofit/>
-          </a:bodyPr>
-          <a:lstStyle xmlns:a="http://schemas.openxmlformats.org/drawingml/2006/main"/>
-          <a:p xmlns:a="http://schemas.openxmlformats.org/drawingml/2006/main">
-            <a:pPr algn="l">
-              <a:buNone/>
-              <a:defRPr sz="3300" b="1">
-                <a:solidFill>
-                  <a:srgbClr val="174A2B"/>
-                </a:solidFill>
-                <a:latin typeface="Arial"/>
-                <a:ea typeface="Arial"/>
-                <a:cs typeface="Arial"/>
-              </a:defRPr>
-            </a:pPr>
-            <a:r>
-              <a:rPr sz="3300" b="1">
-                <a:solidFill>
-                  <a:srgbClr val="0F3C65"/>
-                </a:solidFill>
-                <a:latin typeface="League Spartan"/>
-                <a:ea typeface="League Spartan"/>
-                <a:cs typeface="League Spartan"/>
-              </a:rPr>
-              <a:t>Olhe. Fale. Confirme.</a:t>
-            </a:r>
-          </a:p>
-        </p:txBody>
-      </p:sp>
-      <p:sp>
-        <p:nvSpPr>
-          <p:cNvPr id="4" name="close-bar">
-            <a:extLst xmlns:a="http://schemas.openxmlformats.org/drawingml/2006/main">
-              <a:ext uri="{FF2B5EF4-FFF2-40B4-BE49-F238E27FC236}">
-                <a16:creationId xmlns:a16="http://schemas.microsoft.com/office/drawing/2014/main" id="{C6AC9AA4-0FF6-4476-936F-C4A2E38B4428}"/>
-              </a:ext>
-            </a:extLst>
-          </p:cNvPr>
-          <p:cNvSpPr>
-            <a:spLocks xmlns:a="http://schemas.openxmlformats.org/drawingml/2006/main" noGrp="1"/>
-          </p:cNvSpPr>
-          <p:nvPr/>
-        </p:nvSpPr>
-        <p:spPr>
-          <a:xfrm xmlns:a="http://schemas.openxmlformats.org/drawingml/2006/main">
-            <a:off x="0" y="6524625"/>
-            <a:ext cx="12192000" cy="333375"/>
-          </a:xfrm>
-          <a:prstGeom xmlns:a="http://schemas.openxmlformats.org/drawingml/2006/main" prst="rect">
-            <a:avLst/>
-          </a:prstGeom>
-          <a:solidFill xmlns:a="http://schemas.openxmlformats.org/drawingml/2006/main">
-            <a:srgbClr val="FCC931"/>
-          </a:solidFill>
-          <a:ln xmlns:a="http://schemas.openxmlformats.org/drawingml/2006/main" w="0">
-            <a:noFill/>
-            <a:prstDash val="solid"/>
-          </a:ln>
-        </p:spPr>
-      </p:sp>
       <p:pic>
         <p:nvPicPr>
           <p:cNvPr id="9" name=""/>
@@ -5205,18 +5057,168 @@
         </p:nvPicPr>
         <p:blipFill>
           <a:blip xmlns:r="http://schemas.openxmlformats.org/officeDocument/2006/relationships" xmlns:a="http://schemas.openxmlformats.org/drawingml/2006/main" r:embed="R2b188eb3d64743e6"/>
+          <a:srcRect xmlns:a="http://schemas.openxmlformats.org/drawingml/2006/main" l="0" t="34000" r="4000" b="34000"/>
           <a:stretch xmlns:a="http://schemas.openxmlformats.org/drawingml/2006/main"/>
         </p:blipFill>
         <p:spPr>
           <a:xfrm xmlns:a="http://schemas.openxmlformats.org/drawingml/2006/main">
             <a:off x="457200" y="363118"/>
-            <a:ext cx="4000500" cy="1169239"/>
+            <a:ext cx="4000500" cy="1333500"/>
           </a:xfrm>
           <a:prstGeom xmlns:a="http://schemas.openxmlformats.org/drawingml/2006/main" prst="rect">
             <a:avLst/>
           </a:prstGeom>
         </p:spPr>
       </p:pic>
+      <p:sp>
+        <p:nvSpPr>
+          <p:cNvPr id="2" name="close-thesis">
+            <a:extLst xmlns:a="http://schemas.openxmlformats.org/drawingml/2006/main">
+              <a:ext uri="{FF2B5EF4-FFF2-40B4-BE49-F238E27FC236}">
+                <a16:creationId xmlns:a16="http://schemas.microsoft.com/office/drawing/2014/main" id="{28E06A39-AA9A-4146-BBA9-C188263EB56B}"/>
+              </a:ext>
+            </a:extLst>
+          </p:cNvPr>
+          <p:cNvSpPr>
+            <a:spLocks xmlns:a="http://schemas.openxmlformats.org/drawingml/2006/main" noGrp="1"/>
+          </p:cNvSpPr>
+          <p:nvPr/>
+        </p:nvSpPr>
+        <p:spPr>
+          <a:xfrm xmlns:a="http://schemas.openxmlformats.org/drawingml/2006/main">
+            <a:off x="457200" y="1714500"/>
+            <a:ext cx="10287000" cy="2286000"/>
+          </a:xfrm>
+          <a:prstGeom xmlns:a="http://schemas.openxmlformats.org/drawingml/2006/main" prst="rect">
+            <a:avLst/>
+          </a:prstGeom>
+          <a:noFill xmlns:a="http://schemas.openxmlformats.org/drawingml/2006/main"/>
+          <a:ln xmlns:a="http://schemas.openxmlformats.org/drawingml/2006/main" w="0">
+            <a:noFill/>
+            <a:prstDash val="solid"/>
+          </a:ln>
+        </p:spPr>
+        <p:txBody>
+          <a:bodyPr xmlns:a="http://schemas.openxmlformats.org/drawingml/2006/main" anchor="b">
+            <a:noAutofit/>
+          </a:bodyPr>
+          <a:lstStyle xmlns:a="http://schemas.openxmlformats.org/drawingml/2006/main"/>
+          <a:p xmlns:a="http://schemas.openxmlformats.org/drawingml/2006/main">
+            <a:pPr algn="l">
+              <a:buNone/>
+              <a:defRPr sz="5250" b="1">
+                <a:solidFill>
+                  <a:srgbClr val="111814"/>
+                </a:solidFill>
+                <a:latin typeface="Arial"/>
+                <a:ea typeface="Arial"/>
+                <a:cs typeface="Arial"/>
+              </a:defRPr>
+            </a:pPr>
+            <a:r>
+              <a:rPr sz="5250" b="1">
+                <a:solidFill>
+                  <a:srgbClr val="3C4C1E"/>
+                </a:solidFill>
+                <a:latin typeface="League Spartan"/>
+                <a:ea typeface="League Spartan"/>
+                <a:cs typeface="League Spartan"/>
+              </a:rPr>
+              <a:t>O futuro do campo não precisa de mais telas.</a:t>
+            </a:r>
+          </a:p>
+        </p:txBody>
+      </p:sp>
+      <p:sp>
+        <p:nvSpPr>
+          <p:cNvPr id="3" name="close-tagline">
+            <a:extLst xmlns:a="http://schemas.openxmlformats.org/drawingml/2006/main">
+              <a:ext uri="{FF2B5EF4-FFF2-40B4-BE49-F238E27FC236}">
+                <a16:creationId xmlns:a16="http://schemas.microsoft.com/office/drawing/2014/main" id="{0753BFD4-8DB1-4577-BAA0-53EE2B0BAAE9}"/>
+              </a:ext>
+            </a:extLst>
+          </p:cNvPr>
+          <p:cNvSpPr>
+            <a:spLocks xmlns:a="http://schemas.openxmlformats.org/drawingml/2006/main" noGrp="1"/>
+          </p:cNvSpPr>
+          <p:nvPr/>
+        </p:nvSpPr>
+        <p:spPr>
+          <a:xfrm xmlns:a="http://schemas.openxmlformats.org/drawingml/2006/main">
+            <a:off x="457200" y="4810125"/>
+            <a:ext cx="6858000" cy="762000"/>
+          </a:xfrm>
+          <a:prstGeom xmlns:a="http://schemas.openxmlformats.org/drawingml/2006/main" prst="rect">
+            <a:avLst/>
+          </a:prstGeom>
+          <a:noFill xmlns:a="http://schemas.openxmlformats.org/drawingml/2006/main"/>
+          <a:ln xmlns:a="http://schemas.openxmlformats.org/drawingml/2006/main" w="0">
+            <a:noFill/>
+            <a:prstDash val="solid"/>
+          </a:ln>
+        </p:spPr>
+        <p:txBody>
+          <a:bodyPr xmlns:a="http://schemas.openxmlformats.org/drawingml/2006/main" anchor="t">
+            <a:noAutofit/>
+          </a:bodyPr>
+          <a:lstStyle xmlns:a="http://schemas.openxmlformats.org/drawingml/2006/main"/>
+          <a:p xmlns:a="http://schemas.openxmlformats.org/drawingml/2006/main">
+            <a:pPr algn="l">
+              <a:buNone/>
+              <a:defRPr sz="3300" b="1">
+                <a:solidFill>
+                  <a:srgbClr val="174A2B"/>
+                </a:solidFill>
+                <a:latin typeface="Arial"/>
+                <a:ea typeface="Arial"/>
+                <a:cs typeface="Arial"/>
+              </a:defRPr>
+            </a:pPr>
+            <a:r>
+              <a:rPr sz="3300" b="1">
+                <a:solidFill>
+                  <a:srgbClr val="0F3C65"/>
+                </a:solidFill>
+                <a:latin typeface="League Spartan"/>
+                <a:ea typeface="League Spartan"/>
+                <a:cs typeface="League Spartan"/>
+              </a:rPr>
+              <a:t>Olhe. Fale. Confirme.</a:t>
+            </a:r>
+          </a:p>
+        </p:txBody>
+      </p:sp>
+      <p:sp>
+        <p:nvSpPr>
+          <p:cNvPr id="4" name="close-bar">
+            <a:extLst xmlns:a="http://schemas.openxmlformats.org/drawingml/2006/main">
+              <a:ext uri="{FF2B5EF4-FFF2-40B4-BE49-F238E27FC236}">
+                <a16:creationId xmlns:a16="http://schemas.microsoft.com/office/drawing/2014/main" id="{C6AC9AA4-0FF6-4476-936F-C4A2E38B4428}"/>
+              </a:ext>
+            </a:extLst>
+          </p:cNvPr>
+          <p:cNvSpPr>
+            <a:spLocks xmlns:a="http://schemas.openxmlformats.org/drawingml/2006/main" noGrp="1"/>
+          </p:cNvSpPr>
+          <p:nvPr/>
+        </p:nvSpPr>
+        <p:spPr>
+          <a:xfrm xmlns:a="http://schemas.openxmlformats.org/drawingml/2006/main">
+            <a:off x="0" y="6524625"/>
+            <a:ext cx="12192000" cy="333375"/>
+          </a:xfrm>
+          <a:prstGeom xmlns:a="http://schemas.openxmlformats.org/drawingml/2006/main" prst="rect">
+            <a:avLst/>
+          </a:prstGeom>
+          <a:solidFill xmlns:a="http://schemas.openxmlformats.org/drawingml/2006/main">
+            <a:srgbClr val="FCC931"/>
+          </a:solidFill>
+          <a:ln xmlns:a="http://schemas.openxmlformats.org/drawingml/2006/main" w="0">
+            <a:noFill/>
+            <a:prstDash val="solid"/>
+          </a:ln>
+        </p:spPr>
+      </p:sp>
     </p:spTree>
     <p:extLst>
       <p:ext uri="{BB962C8B-B14F-4D97-AF65-F5344CB8AC3E}">

</xml_diff>